<commit_message>
EP2 v2: F1 redacted-numbers tease, EP1 metric labels
</commit_message>
<xml_diff>
--- a/content-assets/lagoons-ep2/lagoons-ep2-gone-wrong.pptx
+++ b/content-assets/lagoons-ep2/lagoons-ep2-gone-wrong.pptx
@@ -1367,8 +1367,8 @@
         </p:nvSpPr>
         <p:spPr>
           <a:xfrm>
-            <a:off x="0" y="1371600"/>
-            <a:ext cx="12188952" cy="457200"/>
+            <a:off x="0" y="1051560"/>
+            <a:ext cx="12188952" cy="640080"/>
           </a:xfrm>
           <a:prstGeom prst="rect">
             <a:avLst/>
@@ -1384,7 +1384,46 @@
               <a:buNone/>
             </a:pPr>
             <a:r>
-              <a:rPr lang="en-US" sz="2200" b="1" spc="500" kern="0" dirty="0">
+              <a:rPr lang="en-US" sz="3600" b="1" dirty="0">
+                <a:solidFill>
+                  <a:srgbClr val="F5EDE0"/>
+                </a:solidFill>
+                <a:latin typeface="Palatino Linotype" pitchFamily="34" charset="0"/>
+                <a:ea typeface="Palatino Linotype" pitchFamily="34" charset="-122"/>
+                <a:cs typeface="Palatino Linotype" pitchFamily="34" charset="-120"/>
+              </a:rPr>
+              <a:t>Let’s run the numbers.</a:t>
+            </a:r>
+            <a:endParaRPr lang="en-US" sz="3600" dirty="0"/>
+          </a:p>
+        </p:txBody>
+      </p:sp>
+      <p:sp>
+        <p:nvSpPr>
+          <p:cNvPr id="4" name="Text 2"/>
+          <p:cNvSpPr/>
+          <p:nvPr/>
+        </p:nvSpPr>
+        <p:spPr>
+          <a:xfrm>
+            <a:off x="822960" y="1920240"/>
+            <a:ext cx="4754880" cy="365760"/>
+          </a:xfrm>
+          <a:prstGeom prst="rect">
+            <a:avLst/>
+          </a:prstGeom>
+          <a:noFill/>
+          <a:ln/>
+        </p:spPr>
+        <p:txBody>
+          <a:bodyPr wrap="square" lIns="0" tIns="0" rIns="0" bIns="0" rtlCol="0" anchor="ctr"/>
+          <a:lstStyle/>
+          <a:p>
+            <a:pPr indent="0" marL="0">
+              <a:buNone/>
+            </a:pPr>
+            <a:r>
+              <a:rPr lang="en-US" sz="1500" dirty="0">
                 <a:solidFill>
                   <a:srgbClr val="8FA898"/>
                 </a:solidFill>
@@ -1392,22 +1431,455 @@
                 <a:ea typeface="Calibri" pitchFamily="34" charset="-122"/>
                 <a:cs typeface="Calibri" pitchFamily="34" charset="-120"/>
               </a:rPr>
-              <a:t>BOUGHT  SEP 2024</a:t>
-            </a:r>
-            <a:endParaRPr lang="en-US" sz="2200" dirty="0"/>
-          </a:p>
-        </p:txBody>
-      </p:sp>
-      <p:sp>
-        <p:nvSpPr>
-          <p:cNvPr id="4" name="Text 2"/>
-          <p:cNvSpPr/>
-          <p:nvPr/>
-        </p:nvSpPr>
-        <p:spPr>
-          <a:xfrm>
-            <a:off x="0" y="1828800"/>
-            <a:ext cx="12188952" cy="1005840"/>
+              <a:t>Bought from the developer</a:t>
+            </a:r>
+            <a:endParaRPr lang="en-US" sz="1500" dirty="0"/>
+          </a:p>
+        </p:txBody>
+      </p:sp>
+      <p:sp>
+        <p:nvSpPr>
+          <p:cNvPr id="5" name="Shape 3"/>
+          <p:cNvSpPr/>
+          <p:nvPr/>
+        </p:nvSpPr>
+        <p:spPr>
+          <a:xfrm>
+            <a:off x="822960" y="2304288"/>
+            <a:ext cx="3291840" cy="457200"/>
+          </a:xfrm>
+          <a:prstGeom prst="rect">
+            <a:avLst/>
+          </a:prstGeom>
+          <a:solidFill>
+            <a:srgbClr val="C9A84C"/>
+          </a:solidFill>
+          <a:ln/>
+        </p:spPr>
+      </p:sp>
+      <p:sp>
+        <p:nvSpPr>
+          <p:cNvPr id="6" name="Text 4"/>
+          <p:cNvSpPr/>
+          <p:nvPr/>
+        </p:nvSpPr>
+        <p:spPr>
+          <a:xfrm>
+            <a:off x="822960" y="2944368"/>
+            <a:ext cx="4754880" cy="365760"/>
+          </a:xfrm>
+          <a:prstGeom prst="rect">
+            <a:avLst/>
+          </a:prstGeom>
+          <a:noFill/>
+          <a:ln/>
+        </p:spPr>
+        <p:txBody>
+          <a:bodyPr wrap="square" lIns="0" tIns="0" rIns="0" bIns="0" rtlCol="0" anchor="ctr"/>
+          <a:lstStyle/>
+          <a:p>
+            <a:pPr indent="0" marL="0">
+              <a:buNone/>
+            </a:pPr>
+            <a:r>
+              <a:rPr lang="en-US" sz="1500" dirty="0">
+                <a:solidFill>
+                  <a:srgbClr val="8FA898"/>
+                </a:solidFill>
+                <a:latin typeface="Calibri" pitchFamily="34" charset="0"/>
+                <a:ea typeface="Calibri" pitchFamily="34" charset="-122"/>
+                <a:cs typeface="Calibri" pitchFamily="34" charset="-120"/>
+              </a:rPr>
+              <a:t>Sold</a:t>
+            </a:r>
+            <a:endParaRPr lang="en-US" sz="1500" dirty="0"/>
+          </a:p>
+        </p:txBody>
+      </p:sp>
+      <p:sp>
+        <p:nvSpPr>
+          <p:cNvPr id="7" name="Shape 5"/>
+          <p:cNvSpPr/>
+          <p:nvPr/>
+        </p:nvSpPr>
+        <p:spPr>
+          <a:xfrm>
+            <a:off x="822960" y="3328416"/>
+            <a:ext cx="3291840" cy="457200"/>
+          </a:xfrm>
+          <a:prstGeom prst="rect">
+            <a:avLst/>
+          </a:prstGeom>
+          <a:solidFill>
+            <a:srgbClr val="C9A84C"/>
+          </a:solidFill>
+          <a:ln/>
+        </p:spPr>
+      </p:sp>
+      <p:sp>
+        <p:nvSpPr>
+          <p:cNvPr id="8" name="Text 6"/>
+          <p:cNvSpPr/>
+          <p:nvPr/>
+        </p:nvSpPr>
+        <p:spPr>
+          <a:xfrm>
+            <a:off x="822960" y="3968496"/>
+            <a:ext cx="4754880" cy="365760"/>
+          </a:xfrm>
+          <a:prstGeom prst="rect">
+            <a:avLst/>
+          </a:prstGeom>
+          <a:noFill/>
+          <a:ln/>
+        </p:spPr>
+        <p:txBody>
+          <a:bodyPr wrap="square" lIns="0" tIns="0" rIns="0" bIns="0" rtlCol="0" anchor="ctr"/>
+          <a:lstStyle/>
+          <a:p>
+            <a:pPr indent="0" marL="0">
+              <a:buNone/>
+            </a:pPr>
+            <a:r>
+              <a:rPr lang="en-US" sz="1500" dirty="0">
+                <a:solidFill>
+                  <a:srgbClr val="8FA898"/>
+                </a:solidFill>
+                <a:latin typeface="Calibri" pitchFamily="34" charset="0"/>
+                <a:ea typeface="Calibri" pitchFamily="34" charset="-122"/>
+                <a:cs typeface="Calibri" pitchFamily="34" charset="-120"/>
+              </a:rPr>
+              <a:t>Time held</a:t>
+            </a:r>
+            <a:endParaRPr lang="en-US" sz="1500" dirty="0"/>
+          </a:p>
+        </p:txBody>
+      </p:sp>
+      <p:sp>
+        <p:nvSpPr>
+          <p:cNvPr id="9" name="Shape 7"/>
+          <p:cNvSpPr/>
+          <p:nvPr/>
+        </p:nvSpPr>
+        <p:spPr>
+          <a:xfrm>
+            <a:off x="822960" y="4352544"/>
+            <a:ext cx="3291840" cy="457200"/>
+          </a:xfrm>
+          <a:prstGeom prst="rect">
+            <a:avLst/>
+          </a:prstGeom>
+          <a:solidFill>
+            <a:srgbClr val="C9A84C"/>
+          </a:solidFill>
+          <a:ln/>
+        </p:spPr>
+      </p:sp>
+      <p:sp>
+        <p:nvSpPr>
+          <p:cNvPr id="10" name="Text 8"/>
+          <p:cNvSpPr/>
+          <p:nvPr/>
+        </p:nvSpPr>
+        <p:spPr>
+          <a:xfrm>
+            <a:off x="822960" y="4992624"/>
+            <a:ext cx="4754880" cy="365760"/>
+          </a:xfrm>
+          <a:prstGeom prst="rect">
+            <a:avLst/>
+          </a:prstGeom>
+          <a:noFill/>
+          <a:ln/>
+        </p:spPr>
+        <p:txBody>
+          <a:bodyPr wrap="square" lIns="0" tIns="0" rIns="0" bIns="0" rtlCol="0" anchor="ctr"/>
+          <a:lstStyle/>
+          <a:p>
+            <a:pPr indent="0" marL="0">
+              <a:buNone/>
+            </a:pPr>
+            <a:r>
+              <a:rPr lang="en-US" sz="1500" dirty="0">
+                <a:solidFill>
+                  <a:srgbClr val="8FA898"/>
+                </a:solidFill>
+                <a:latin typeface="Calibri" pitchFamily="34" charset="0"/>
+                <a:ea typeface="Calibri" pitchFamily="34" charset="-122"/>
+                <a:cs typeface="Calibri" pitchFamily="34" charset="-120"/>
+              </a:rPr>
+              <a:t>Price per sqft</a:t>
+            </a:r>
+            <a:endParaRPr lang="en-US" sz="1500" dirty="0"/>
+          </a:p>
+        </p:txBody>
+      </p:sp>
+      <p:sp>
+        <p:nvSpPr>
+          <p:cNvPr id="11" name="Shape 9"/>
+          <p:cNvSpPr/>
+          <p:nvPr/>
+        </p:nvSpPr>
+        <p:spPr>
+          <a:xfrm>
+            <a:off x="822960" y="5376672"/>
+            <a:ext cx="3291840" cy="457200"/>
+          </a:xfrm>
+          <a:prstGeom prst="rect">
+            <a:avLst/>
+          </a:prstGeom>
+          <a:solidFill>
+            <a:srgbClr val="C9A84C"/>
+          </a:solidFill>
+          <a:ln/>
+        </p:spPr>
+      </p:sp>
+      <p:sp>
+        <p:nvSpPr>
+          <p:cNvPr id="12" name="Text 10"/>
+          <p:cNvSpPr/>
+          <p:nvPr/>
+        </p:nvSpPr>
+        <p:spPr>
+          <a:xfrm>
+            <a:off x="6217920" y="1828800"/>
+            <a:ext cx="5303520" cy="320040"/>
+          </a:xfrm>
+          <a:prstGeom prst="rect">
+            <a:avLst/>
+          </a:prstGeom>
+          <a:noFill/>
+          <a:ln/>
+        </p:spPr>
+        <p:txBody>
+          <a:bodyPr wrap="square" lIns="0" tIns="0" rIns="0" bIns="0" rtlCol="0" anchor="ctr"/>
+          <a:lstStyle/>
+          <a:p>
+            <a:pPr indent="0" marL="0">
+              <a:buNone/>
+            </a:pPr>
+            <a:r>
+              <a:rPr lang="en-US" sz="1400" b="1" spc="300" kern="0" dirty="0">
+                <a:solidFill>
+                  <a:srgbClr val="C9A84C"/>
+                </a:solidFill>
+                <a:latin typeface="Calibri" pitchFamily="34" charset="0"/>
+                <a:ea typeface="Calibri" pitchFamily="34" charset="-122"/>
+                <a:cs typeface="Calibri" pitchFamily="34" charset="-120"/>
+              </a:rPr>
+              <a:t>RESULT</a:t>
+            </a:r>
+            <a:endParaRPr lang="en-US" sz="1400" dirty="0"/>
+          </a:p>
+        </p:txBody>
+      </p:sp>
+      <p:sp>
+        <p:nvSpPr>
+          <p:cNvPr id="13" name="Shape 11"/>
+          <p:cNvSpPr/>
+          <p:nvPr/>
+        </p:nvSpPr>
+        <p:spPr>
+          <a:xfrm>
+            <a:off x="6217920" y="2194560"/>
+            <a:ext cx="4206240" cy="868680"/>
+          </a:xfrm>
+          <a:prstGeom prst="rect">
+            <a:avLst/>
+          </a:prstGeom>
+          <a:solidFill>
+            <a:srgbClr val="E8C96B"/>
+          </a:solidFill>
+          <a:ln/>
+        </p:spPr>
+      </p:sp>
+      <p:sp>
+        <p:nvSpPr>
+          <p:cNvPr id="14" name="Text 12"/>
+          <p:cNvSpPr/>
+          <p:nvPr/>
+        </p:nvSpPr>
+        <p:spPr>
+          <a:xfrm>
+            <a:off x="6217920" y="3520440"/>
+            <a:ext cx="3017520" cy="457200"/>
+          </a:xfrm>
+          <a:prstGeom prst="rect">
+            <a:avLst/>
+          </a:prstGeom>
+          <a:noFill/>
+          <a:ln/>
+        </p:spPr>
+        <p:txBody>
+          <a:bodyPr wrap="square" lIns="0" tIns="0" rIns="0" bIns="0" rtlCol="0" anchor="ctr"/>
+          <a:lstStyle/>
+          <a:p>
+            <a:pPr indent="0" marL="0">
+              <a:buNone/>
+            </a:pPr>
+            <a:r>
+              <a:rPr lang="en-US" sz="1600" dirty="0">
+                <a:solidFill>
+                  <a:srgbClr val="8FA898"/>
+                </a:solidFill>
+                <a:latin typeface="Calibri" pitchFamily="34" charset="0"/>
+                <a:ea typeface="Calibri" pitchFamily="34" charset="-122"/>
+                <a:cs typeface="Calibri" pitchFamily="34" charset="-120"/>
+              </a:rPr>
+              <a:t>ROI on full price</a:t>
+            </a:r>
+            <a:endParaRPr lang="en-US" sz="1600" dirty="0"/>
+          </a:p>
+        </p:txBody>
+      </p:sp>
+      <p:sp>
+        <p:nvSpPr>
+          <p:cNvPr id="15" name="Shape 13"/>
+          <p:cNvSpPr/>
+          <p:nvPr/>
+        </p:nvSpPr>
+        <p:spPr>
+          <a:xfrm>
+            <a:off x="9235440" y="3474720"/>
+            <a:ext cx="2011680" cy="457200"/>
+          </a:xfrm>
+          <a:prstGeom prst="rect">
+            <a:avLst/>
+          </a:prstGeom>
+          <a:solidFill>
+            <a:srgbClr val="C9A84C"/>
+          </a:solidFill>
+          <a:ln/>
+        </p:spPr>
+      </p:sp>
+      <p:sp>
+        <p:nvSpPr>
+          <p:cNvPr id="16" name="Text 14"/>
+          <p:cNvSpPr/>
+          <p:nvPr/>
+        </p:nvSpPr>
+        <p:spPr>
+          <a:xfrm>
+            <a:off x="6217920" y="4361688"/>
+            <a:ext cx="3017520" cy="457200"/>
+          </a:xfrm>
+          <a:prstGeom prst="rect">
+            <a:avLst/>
+          </a:prstGeom>
+          <a:noFill/>
+          <a:ln/>
+        </p:spPr>
+        <p:txBody>
+          <a:bodyPr wrap="square" lIns="0" tIns="0" rIns="0" bIns="0" rtlCol="0" anchor="ctr"/>
+          <a:lstStyle/>
+          <a:p>
+            <a:pPr indent="0" marL="0">
+              <a:buNone/>
+            </a:pPr>
+            <a:r>
+              <a:rPr lang="en-US" sz="1600" dirty="0">
+                <a:solidFill>
+                  <a:srgbClr val="8FA898"/>
+                </a:solidFill>
+                <a:latin typeface="Calibri" pitchFamily="34" charset="0"/>
+                <a:ea typeface="Calibri" pitchFamily="34" charset="-122"/>
+                <a:cs typeface="Calibri" pitchFamily="34" charset="-120"/>
+              </a:rPr>
+              <a:t>IRR (annualised)</a:t>
+            </a:r>
+            <a:endParaRPr lang="en-US" sz="1600" dirty="0"/>
+          </a:p>
+        </p:txBody>
+      </p:sp>
+      <p:sp>
+        <p:nvSpPr>
+          <p:cNvPr id="17" name="Shape 15"/>
+          <p:cNvSpPr/>
+          <p:nvPr/>
+        </p:nvSpPr>
+        <p:spPr>
+          <a:xfrm>
+            <a:off x="9235440" y="4315968"/>
+            <a:ext cx="2011680" cy="457200"/>
+          </a:xfrm>
+          <a:prstGeom prst="rect">
+            <a:avLst/>
+          </a:prstGeom>
+          <a:solidFill>
+            <a:srgbClr val="C9A84C"/>
+          </a:solidFill>
+          <a:ln/>
+        </p:spPr>
+      </p:sp>
+      <p:sp>
+        <p:nvSpPr>
+          <p:cNvPr id="18" name="Text 16"/>
+          <p:cNvSpPr/>
+          <p:nvPr/>
+        </p:nvSpPr>
+        <p:spPr>
+          <a:xfrm>
+            <a:off x="6217920" y="5202936"/>
+            <a:ext cx="3017520" cy="457200"/>
+          </a:xfrm>
+          <a:prstGeom prst="rect">
+            <a:avLst/>
+          </a:prstGeom>
+          <a:noFill/>
+          <a:ln/>
+        </p:spPr>
+        <p:txBody>
+          <a:bodyPr wrap="square" lIns="0" tIns="0" rIns="0" bIns="0" rtlCol="0" anchor="ctr"/>
+          <a:lstStyle/>
+          <a:p>
+            <a:pPr indent="0" marL="0">
+              <a:buNone/>
+            </a:pPr>
+            <a:r>
+              <a:rPr lang="en-US" sz="1600" dirty="0">
+                <a:solidFill>
+                  <a:srgbClr val="8FA898"/>
+                </a:solidFill>
+                <a:latin typeface="Calibri" pitchFamily="34" charset="0"/>
+                <a:ea typeface="Calibri" pitchFamily="34" charset="-122"/>
+                <a:cs typeface="Calibri" pitchFamily="34" charset="-120"/>
+              </a:rPr>
+              <a:t>Cost per month held</a:t>
+            </a:r>
+            <a:endParaRPr lang="en-US" sz="1600" dirty="0"/>
+          </a:p>
+        </p:txBody>
+      </p:sp>
+      <p:sp>
+        <p:nvSpPr>
+          <p:cNvPr id="19" name="Shape 17"/>
+          <p:cNvSpPr/>
+          <p:nvPr/>
+        </p:nvSpPr>
+        <p:spPr>
+          <a:xfrm>
+            <a:off x="9235440" y="5157216"/>
+            <a:ext cx="2011680" cy="457200"/>
+          </a:xfrm>
+          <a:prstGeom prst="rect">
+            <a:avLst/>
+          </a:prstGeom>
+          <a:solidFill>
+            <a:srgbClr val="C9A84C"/>
+          </a:solidFill>
+          <a:ln/>
+        </p:spPr>
+      </p:sp>
+      <p:sp>
+        <p:nvSpPr>
+          <p:cNvPr id="20" name="Text 18"/>
+          <p:cNvSpPr/>
+          <p:nvPr/>
+        </p:nvSpPr>
+        <p:spPr>
+          <a:xfrm>
+            <a:off x="0" y="6035040"/>
+            <a:ext cx="12188952" cy="411480"/>
           </a:xfrm>
           <a:prstGeom prst="rect">
             <a:avLst/>
@@ -1423,134 +1895,17 @@
               <a:buNone/>
             </a:pPr>
             <a:r>
-              <a:rPr lang="en-US" sz="7200" b="1" dirty="0">
-                <a:solidFill>
-                  <a:srgbClr val="F5EDE0"/>
+              <a:rPr lang="en-US" sz="1900" dirty="0">
+                <a:solidFill>
+                  <a:srgbClr val="C9A84C"/>
                 </a:solidFill>
                 <a:latin typeface="Palatino Linotype" pitchFamily="34" charset="0"/>
                 <a:ea typeface="Palatino Linotype" pitchFamily="34" charset="-122"/>
                 <a:cs typeface="Palatino Linotype" pitchFamily="34" charset="-120"/>
               </a:rPr>
-              <a:t>Đ3,082,860</a:t>
-            </a:r>
-            <a:endParaRPr lang="en-US" sz="7200" dirty="0"/>
-          </a:p>
-        </p:txBody>
-      </p:sp>
-      <p:sp>
-        <p:nvSpPr>
-          <p:cNvPr id="5" name="Text 3"/>
-          <p:cNvSpPr/>
-          <p:nvPr/>
-        </p:nvSpPr>
-        <p:spPr>
-          <a:xfrm>
-            <a:off x="0" y="3108960"/>
-            <a:ext cx="12188952" cy="457200"/>
-          </a:xfrm>
-          <a:prstGeom prst="rect">
-            <a:avLst/>
-          </a:prstGeom>
-          <a:noFill/>
-          <a:ln/>
-        </p:spPr>
-        <p:txBody>
-          <a:bodyPr wrap="square" lIns="0" tIns="0" rIns="0" bIns="0" rtlCol="0" anchor="ctr"/>
-          <a:lstStyle/>
-          <a:p>
-            <a:pPr algn="ctr" indent="0" marL="0">
-              <a:buNone/>
-            </a:pPr>
-            <a:r>
-              <a:rPr lang="en-US" sz="2200" b="1" spc="500" kern="0" dirty="0">
-                <a:solidFill>
-                  <a:srgbClr val="8FA898"/>
-                </a:solidFill>
-                <a:latin typeface="Calibri" pitchFamily="34" charset="0"/>
-                <a:ea typeface="Calibri" pitchFamily="34" charset="-122"/>
-                <a:cs typeface="Calibri" pitchFamily="34" charset="-120"/>
-              </a:rPr>
-              <a:t>SOLD  JUN 2026</a:t>
-            </a:r>
-            <a:endParaRPr lang="en-US" sz="2200" dirty="0"/>
-          </a:p>
-        </p:txBody>
-      </p:sp>
-      <p:sp>
-        <p:nvSpPr>
-          <p:cNvPr id="6" name="Text 4"/>
-          <p:cNvSpPr/>
-          <p:nvPr/>
-        </p:nvSpPr>
-        <p:spPr>
-          <a:xfrm>
-            <a:off x="0" y="3566160"/>
-            <a:ext cx="12188952" cy="1005840"/>
-          </a:xfrm>
-          <a:prstGeom prst="rect">
-            <a:avLst/>
-          </a:prstGeom>
-          <a:noFill/>
-          <a:ln/>
-        </p:spPr>
-        <p:txBody>
-          <a:bodyPr wrap="square" lIns="0" tIns="0" rIns="0" bIns="0" rtlCol="0" anchor="ctr"/>
-          <a:lstStyle/>
-          <a:p>
-            <a:pPr algn="ctr" indent="0" marL="0">
-              <a:buNone/>
-            </a:pPr>
-            <a:r>
-              <a:rPr lang="en-US" sz="7200" b="1" dirty="0">
-                <a:solidFill>
-                  <a:srgbClr val="E8C96B"/>
-                </a:solidFill>
-                <a:latin typeface="Palatino Linotype" pitchFamily="34" charset="0"/>
-                <a:ea typeface="Palatino Linotype" pitchFamily="34" charset="-122"/>
-                <a:cs typeface="Palatino Linotype" pitchFamily="34" charset="-120"/>
-              </a:rPr>
-              <a:t>Đ2,500,000</a:t>
-            </a:r>
-            <a:endParaRPr lang="en-US" sz="7200" dirty="0"/>
-          </a:p>
-        </p:txBody>
-      </p:sp>
-      <p:sp>
-        <p:nvSpPr>
-          <p:cNvPr id="7" name="Text 5"/>
-          <p:cNvSpPr/>
-          <p:nvPr/>
-        </p:nvSpPr>
-        <p:spPr>
-          <a:xfrm>
-            <a:off x="0" y="4937760"/>
-            <a:ext cx="12188952" cy="1097280"/>
-          </a:xfrm>
-          <a:prstGeom prst="rect">
-            <a:avLst/>
-          </a:prstGeom>
-          <a:noFill/>
-          <a:ln/>
-        </p:spPr>
-        <p:txBody>
-          <a:bodyPr wrap="square" lIns="0" tIns="0" rIns="0" bIns="0" rtlCol="0" anchor="ctr"/>
-          <a:lstStyle/>
-          <a:p>
-            <a:pPr algn="ctr" indent="0" marL="0">
-              <a:buNone/>
-            </a:pPr>
-            <a:r>
-              <a:rPr lang="en-US" sz="8000" b="1" dirty="0">
-                <a:solidFill>
-                  <a:srgbClr val="C9A84C"/>
-                </a:solidFill>
-                <a:latin typeface="Palatino Linotype" pitchFamily="34" charset="0"/>
-                <a:ea typeface="Palatino Linotype" pitchFamily="34" charset="-122"/>
-                <a:cs typeface="Palatino Linotype" pitchFamily="34" charset="-120"/>
-              </a:rPr>
-              <a:t>−Đ582,860</a:t>
-            </a:r>
-            <a:endParaRPr lang="en-US" sz="8000" dirty="0"/>
+              <a:t>A real unit · a real transaction record · DAMAC Lagoons</a:t>
+            </a:r>
+            <a:endParaRPr lang="en-US" sz="1900" dirty="0"/>
           </a:p>
         </p:txBody>
       </p:sp>
@@ -2409,7 +2764,7 @@
                 <a:ea typeface="Calibri" pitchFamily="34" charset="-122"/>
                 <a:cs typeface="Calibri" pitchFamily="34" charset="-120"/>
               </a:rPr>
-              <a:t>Return</a:t>
+              <a:t>ROI on full price</a:t>
             </a:r>
             <a:endParaRPr lang="en-US" sz="1600" dirty="0"/>
           </a:p>
@@ -2487,7 +2842,7 @@
                 <a:ea typeface="Calibri" pitchFamily="34" charset="-122"/>
                 <a:cs typeface="Calibri" pitchFamily="34" charset="-120"/>
               </a:rPr>
-              <a:t>Annualised</a:t>
+              <a:t>IRR (annualised)</a:t>
             </a:r>
             <a:endParaRPr lang="en-US" sz="1600" dirty="0"/>
           </a:p>

</xml_diff>

<commit_message>
EP2 v3: full-number opener, ROE row, covered/reveal record pages
</commit_message>
<xml_diff>
--- a/content-assets/lagoons-ep2/lagoons-ep2-gone-wrong.pptx
+++ b/content-assets/lagoons-ep2/lagoons-ep2-gone-wrong.pptx
@@ -11,9 +11,10 @@
     <p:sldId id="259" r:id="rId5"/>
     <p:sldId id="260" r:id="rId6"/>
     <p:sldId id="261" r:id="rId7"/>
+    <p:sldId id="262" r:id="rId8"/>
   </p:sldIdLst>
   <p:notesMasterIdLst>
-    <p:notesMasterId r:id="rId8"/>
+    <p:notesMasterId r:id="rId9"/>
   </p:notesMasterIdLst>
   <p:sldSz cx="12192000" cy="6858000"/>
   <p:notesSz cx="6858000" cy="12192000"/>
@@ -971,6 +972,94 @@
             <a:fld id="{F7021451-1387-4CA6-816F-3879F97B5CBC}" type="slidenum">
               <a:rPr lang="en-US"/>
               <a:t>6</a:t>
+            </a:fld>
+            <a:endParaRPr lang="en-US"/>
+          </a:p>
+        </p:txBody>
+      </p:sp>
+    </p:spTree>
+    <p:extLst>
+      <p:ext uri="{BB962C8B-B14F-4D97-AF65-F5344CB8AC3E}">
+        <p14:creationId xmlns:p14="http://schemas.microsoft.com/office/powerpoint/2010/main" val="1024086991"/>
+      </p:ext>
+    </p:extLst>
+  </p:cSld>
+  <p:clrMapOvr>
+    <a:masterClrMapping/>
+  </p:clrMapOvr>
+</p:notes>
+</file>
+
+<file path=ppt/notesSlides/notesSlide7.xml><?xml version="1.0" encoding="utf-8"?>
+<p:notes xmlns:a="http://schemas.openxmlformats.org/drawingml/2006/main" xmlns:r="http://schemas.openxmlformats.org/officeDocument/2006/relationships" xmlns:p="http://schemas.openxmlformats.org/presentationml/2006/main">
+  <p:cSld>
+    <p:spTree>
+      <p:nvGrpSpPr>
+        <p:cNvPr id="1" name=""/>
+        <p:cNvGrpSpPr/>
+        <p:nvPr/>
+      </p:nvGrpSpPr>
+      <p:grpSpPr>
+        <a:xfrm>
+          <a:off x="0" y="0"/>
+          <a:ext cx="0" cy="0"/>
+          <a:chOff x="0" y="0"/>
+          <a:chExt cx="0" cy="0"/>
+        </a:xfrm>
+      </p:grpSpPr>
+      <p:sp>
+        <p:nvSpPr>
+          <p:cNvPr id="2" name="Slide Image Placeholder 1"/>
+          <p:cNvSpPr>
+            <a:spLocks noGrp="1" noRot="1" noChangeAspect="1"/>
+          </p:cNvSpPr>
+          <p:nvPr>
+            <p:ph type="sldImg"/>
+          </p:nvPr>
+        </p:nvSpPr>
+        <p:spPr/>
+      </p:sp>
+      <p:sp>
+        <p:nvSpPr>
+          <p:cNvPr id="3" name="Notes Placeholder 2"/>
+          <p:cNvSpPr>
+            <a:spLocks noGrp="1"/>
+          </p:cNvSpPr>
+          <p:nvPr>
+            <p:ph type="body" idx="1"/>
+          </p:nvPr>
+        </p:nvSpPr>
+        <p:spPr/>
+        <p:txBody>
+          <a:bodyPr/>
+          <a:lstStyle/>
+          <a:p>
+            <a:r>
+              <a:rPr lang="en-US" dirty="0"/>
+              <a:t/>
+            </a:r>
+            <a:endParaRPr lang="en-US" dirty="0"/>
+          </a:p>
+        </p:txBody>
+      </p:sp>
+      <p:sp>
+        <p:nvSpPr>
+          <p:cNvPr id="4" name="Slide Number Placeholder 3"/>
+          <p:cNvSpPr>
+            <a:spLocks noGrp="1"/>
+          </p:cNvSpPr>
+          <p:nvPr>
+            <p:ph type="sldNum" sz="quarter" idx="10"/>
+          </p:nvPr>
+        </p:nvSpPr>
+        <p:spPr/>
+        <p:txBody>
+          <a:bodyPr/>
+          <a:lstStyle/>
+          <a:p>
+            <a:fld id="{F7021451-1387-4CA6-816F-3879F97B5CBC}" type="slidenum">
+              <a:rPr lang="en-US"/>
+              <a:t>7</a:t>
             </a:fld>
             <a:endParaRPr lang="en-US"/>
           </a:p>
@@ -1367,24 +1456,63 @@
         </p:nvSpPr>
         <p:spPr>
           <a:xfrm>
-            <a:off x="0" y="1051560"/>
-            <a:ext cx="12188952" cy="640080"/>
-          </a:xfrm>
-          <a:prstGeom prst="rect">
-            <a:avLst/>
-          </a:prstGeom>
-          <a:noFill/>
-          <a:ln/>
-        </p:spPr>
-        <p:txBody>
-          <a:bodyPr wrap="square" lIns="0" tIns="0" rIns="0" bIns="0" rtlCol="0" anchor="ctr"/>
-          <a:lstStyle/>
-          <a:p>
-            <a:pPr algn="ctr" indent="0" marL="0">
-              <a:buNone/>
-            </a:pPr>
-            <a:r>
-              <a:rPr lang="en-US" sz="3600" b="1" dirty="0">
+            <a:off x="822960" y="1463040"/>
+            <a:ext cx="4754880" cy="365760"/>
+          </a:xfrm>
+          <a:prstGeom prst="rect">
+            <a:avLst/>
+          </a:prstGeom>
+          <a:noFill/>
+          <a:ln/>
+        </p:spPr>
+        <p:txBody>
+          <a:bodyPr wrap="square" lIns="0" tIns="0" rIns="0" bIns="0" rtlCol="0" anchor="ctr"/>
+          <a:lstStyle/>
+          <a:p>
+            <a:pPr indent="0" marL="0">
+              <a:buNone/>
+            </a:pPr>
+            <a:r>
+              <a:rPr lang="en-US" sz="1500" dirty="0">
+                <a:solidFill>
+                  <a:srgbClr val="8FA898"/>
+                </a:solidFill>
+                <a:latin typeface="Calibri" pitchFamily="34" charset="0"/>
+                <a:ea typeface="Calibri" pitchFamily="34" charset="-122"/>
+                <a:cs typeface="Calibri" pitchFamily="34" charset="-120"/>
+              </a:rPr>
+              <a:t>Bought from the developer</a:t>
+            </a:r>
+            <a:endParaRPr lang="en-US" sz="1500" dirty="0"/>
+          </a:p>
+        </p:txBody>
+      </p:sp>
+      <p:sp>
+        <p:nvSpPr>
+          <p:cNvPr id="4" name="Text 2"/>
+          <p:cNvSpPr/>
+          <p:nvPr/>
+        </p:nvSpPr>
+        <p:spPr>
+          <a:xfrm>
+            <a:off x="822960" y="1810512"/>
+            <a:ext cx="4937760" cy="502920"/>
+          </a:xfrm>
+          <a:prstGeom prst="rect">
+            <a:avLst/>
+          </a:prstGeom>
+          <a:noFill/>
+          <a:ln/>
+        </p:spPr>
+        <p:txBody>
+          <a:bodyPr wrap="square" lIns="0" tIns="0" rIns="0" bIns="0" rtlCol="0" anchor="ctr"/>
+          <a:lstStyle/>
+          <a:p>
+            <a:pPr indent="0" marL="0">
+              <a:buNone/>
+            </a:pPr>
+            <a:r>
+              <a:rPr lang="en-US" sz="2500" b="1" dirty="0">
                 <a:solidFill>
                   <a:srgbClr val="F5EDE0"/>
                 </a:solidFill>
@@ -1392,21 +1520,21 @@
                 <a:ea typeface="Palatino Linotype" pitchFamily="34" charset="-122"/>
                 <a:cs typeface="Palatino Linotype" pitchFamily="34" charset="-120"/>
               </a:rPr>
-              <a:t>Let’s run the numbers.</a:t>
-            </a:r>
-            <a:endParaRPr lang="en-US" sz="3600" dirty="0"/>
-          </a:p>
-        </p:txBody>
-      </p:sp>
-      <p:sp>
-        <p:nvSpPr>
-          <p:cNvPr id="4" name="Text 2"/>
-          <p:cNvSpPr/>
-          <p:nvPr/>
-        </p:nvSpPr>
-        <p:spPr>
-          <a:xfrm>
-            <a:off x="822960" y="1920240"/>
+              <a:t>Đ3,082,860  ·  Sep 2024</a:t>
+            </a:r>
+            <a:endParaRPr lang="en-US" sz="2500" dirty="0"/>
+          </a:p>
+        </p:txBody>
+      </p:sp>
+      <p:sp>
+        <p:nvSpPr>
+          <p:cNvPr id="5" name="Text 3"/>
+          <p:cNvSpPr/>
+          <p:nvPr/>
+        </p:nvSpPr>
+        <p:spPr>
+          <a:xfrm>
+            <a:off x="822960" y="2514600"/>
             <a:ext cx="4754880" cy="365760"/>
           </a:xfrm>
           <a:prstGeom prst="rect">
@@ -1431,7 +1559,7 @@
                 <a:ea typeface="Calibri" pitchFamily="34" charset="-122"/>
                 <a:cs typeface="Calibri" pitchFamily="34" charset="-120"/>
               </a:rPr>
-              <a:t>Bought from the developer</a:t>
+              <a:t>Sold</a:t>
             </a:r>
             <a:endParaRPr lang="en-US" sz="1500" dirty="0"/>
           </a:p>
@@ -1439,33 +1567,52 @@
       </p:sp>
       <p:sp>
         <p:nvSpPr>
-          <p:cNvPr id="5" name="Shape 3"/>
-          <p:cNvSpPr/>
-          <p:nvPr/>
-        </p:nvSpPr>
-        <p:spPr>
-          <a:xfrm>
-            <a:off x="822960" y="2304288"/>
-            <a:ext cx="3291840" cy="457200"/>
-          </a:xfrm>
-          <a:prstGeom prst="rect">
-            <a:avLst/>
-          </a:prstGeom>
-          <a:solidFill>
-            <a:srgbClr val="C9A84C"/>
-          </a:solidFill>
-          <a:ln/>
-        </p:spPr>
-      </p:sp>
-      <p:sp>
-        <p:nvSpPr>
           <p:cNvPr id="6" name="Text 4"/>
           <p:cNvSpPr/>
           <p:nvPr/>
         </p:nvSpPr>
         <p:spPr>
           <a:xfrm>
-            <a:off x="822960" y="2944368"/>
+            <a:off x="822960" y="2862072"/>
+            <a:ext cx="4937760" cy="502920"/>
+          </a:xfrm>
+          <a:prstGeom prst="rect">
+            <a:avLst/>
+          </a:prstGeom>
+          <a:noFill/>
+          <a:ln/>
+        </p:spPr>
+        <p:txBody>
+          <a:bodyPr wrap="square" lIns="0" tIns="0" rIns="0" bIns="0" rtlCol="0" anchor="ctr"/>
+          <a:lstStyle/>
+          <a:p>
+            <a:pPr indent="0" marL="0">
+              <a:buNone/>
+            </a:pPr>
+            <a:r>
+              <a:rPr lang="en-US" sz="2500" b="1" dirty="0">
+                <a:solidFill>
+                  <a:srgbClr val="F5EDE0"/>
+                </a:solidFill>
+                <a:latin typeface="Palatino Linotype" pitchFamily="34" charset="0"/>
+                <a:ea typeface="Palatino Linotype" pitchFamily="34" charset="-122"/>
+                <a:cs typeface="Palatino Linotype" pitchFamily="34" charset="-120"/>
+              </a:rPr>
+              <a:t>Đ2,500,000  ·  Jun 2026</a:t>
+            </a:r>
+            <a:endParaRPr lang="en-US" sz="2500" dirty="0"/>
+          </a:p>
+        </p:txBody>
+      </p:sp>
+      <p:sp>
+        <p:nvSpPr>
+          <p:cNvPr id="7" name="Text 5"/>
+          <p:cNvSpPr/>
+          <p:nvPr/>
+        </p:nvSpPr>
+        <p:spPr>
+          <a:xfrm>
+            <a:off x="822960" y="3566160"/>
             <a:ext cx="4754880" cy="365760"/>
           </a:xfrm>
           <a:prstGeom prst="rect">
@@ -1490,7 +1637,7 @@
                 <a:ea typeface="Calibri" pitchFamily="34" charset="-122"/>
                 <a:cs typeface="Calibri" pitchFamily="34" charset="-120"/>
               </a:rPr>
-              <a:t>Sold</a:t>
+              <a:t>Time held</a:t>
             </a:r>
             <a:endParaRPr lang="en-US" sz="1500" dirty="0"/>
           </a:p>
@@ -1498,33 +1645,52 @@
       </p:sp>
       <p:sp>
         <p:nvSpPr>
-          <p:cNvPr id="7" name="Shape 5"/>
-          <p:cNvSpPr/>
-          <p:nvPr/>
-        </p:nvSpPr>
-        <p:spPr>
-          <a:xfrm>
-            <a:off x="822960" y="3328416"/>
-            <a:ext cx="3291840" cy="457200"/>
-          </a:xfrm>
-          <a:prstGeom prst="rect">
-            <a:avLst/>
-          </a:prstGeom>
-          <a:solidFill>
-            <a:srgbClr val="C9A84C"/>
-          </a:solidFill>
-          <a:ln/>
-        </p:spPr>
-      </p:sp>
-      <p:sp>
-        <p:nvSpPr>
           <p:cNvPr id="8" name="Text 6"/>
           <p:cNvSpPr/>
           <p:nvPr/>
         </p:nvSpPr>
         <p:spPr>
           <a:xfrm>
-            <a:off x="822960" y="3968496"/>
+            <a:off x="822960" y="3913632"/>
+            <a:ext cx="4937760" cy="502920"/>
+          </a:xfrm>
+          <a:prstGeom prst="rect">
+            <a:avLst/>
+          </a:prstGeom>
+          <a:noFill/>
+          <a:ln/>
+        </p:spPr>
+        <p:txBody>
+          <a:bodyPr wrap="square" lIns="0" tIns="0" rIns="0" bIns="0" rtlCol="0" anchor="ctr"/>
+          <a:lstStyle/>
+          <a:p>
+            <a:pPr indent="0" marL="0">
+              <a:buNone/>
+            </a:pPr>
+            <a:r>
+              <a:rPr lang="en-US" sz="2500" b="1" dirty="0">
+                <a:solidFill>
+                  <a:srgbClr val="F5EDE0"/>
+                </a:solidFill>
+                <a:latin typeface="Palatino Linotype" pitchFamily="34" charset="0"/>
+                <a:ea typeface="Palatino Linotype" pitchFamily="34" charset="-122"/>
+                <a:cs typeface="Palatino Linotype" pitchFamily="34" charset="-120"/>
+              </a:rPr>
+              <a:t>21 months</a:t>
+            </a:r>
+            <a:endParaRPr lang="en-US" sz="2500" dirty="0"/>
+          </a:p>
+        </p:txBody>
+      </p:sp>
+      <p:sp>
+        <p:nvSpPr>
+          <p:cNvPr id="9" name="Text 7"/>
+          <p:cNvSpPr/>
+          <p:nvPr/>
+        </p:nvSpPr>
+        <p:spPr>
+          <a:xfrm>
+            <a:off x="822960" y="4617720"/>
             <a:ext cx="4754880" cy="365760"/>
           </a:xfrm>
           <a:prstGeom prst="rect">
@@ -1549,7 +1715,7 @@
                 <a:ea typeface="Calibri" pitchFamily="34" charset="-122"/>
                 <a:cs typeface="Calibri" pitchFamily="34" charset="-120"/>
               </a:rPr>
-              <a:t>Time held</a:t>
+              <a:t>Price per sqft</a:t>
             </a:r>
             <a:endParaRPr lang="en-US" sz="1500" dirty="0"/>
           </a:p>
@@ -1557,82 +1723,81 @@
       </p:sp>
       <p:sp>
         <p:nvSpPr>
-          <p:cNvPr id="9" name="Shape 7"/>
-          <p:cNvSpPr/>
-          <p:nvPr/>
-        </p:nvSpPr>
-        <p:spPr>
-          <a:xfrm>
-            <a:off x="822960" y="4352544"/>
-            <a:ext cx="3291840" cy="457200"/>
-          </a:xfrm>
-          <a:prstGeom prst="rect">
-            <a:avLst/>
-          </a:prstGeom>
-          <a:solidFill>
-            <a:srgbClr val="C9A84C"/>
-          </a:solidFill>
-          <a:ln/>
-        </p:spPr>
-      </p:sp>
-      <p:sp>
-        <p:nvSpPr>
           <p:cNvPr id="10" name="Text 8"/>
           <p:cNvSpPr/>
           <p:nvPr/>
         </p:nvSpPr>
         <p:spPr>
           <a:xfrm>
-            <a:off x="822960" y="4992624"/>
-            <a:ext cx="4754880" cy="365760"/>
-          </a:xfrm>
-          <a:prstGeom prst="rect">
-            <a:avLst/>
-          </a:prstGeom>
-          <a:noFill/>
-          <a:ln/>
-        </p:spPr>
-        <p:txBody>
-          <a:bodyPr wrap="square" lIns="0" tIns="0" rIns="0" bIns="0" rtlCol="0" anchor="ctr"/>
-          <a:lstStyle/>
-          <a:p>
-            <a:pPr indent="0" marL="0">
-              <a:buNone/>
-            </a:pPr>
-            <a:r>
-              <a:rPr lang="en-US" sz="1500" dirty="0">
-                <a:solidFill>
-                  <a:srgbClr val="8FA898"/>
+            <a:off x="822960" y="4965192"/>
+            <a:ext cx="4937760" cy="502920"/>
+          </a:xfrm>
+          <a:prstGeom prst="rect">
+            <a:avLst/>
+          </a:prstGeom>
+          <a:noFill/>
+          <a:ln/>
+        </p:spPr>
+        <p:txBody>
+          <a:bodyPr wrap="square" lIns="0" tIns="0" rIns="0" bIns="0" rtlCol="0" anchor="ctr"/>
+          <a:lstStyle/>
+          <a:p>
+            <a:pPr indent="0" marL="0">
+              <a:buNone/>
+            </a:pPr>
+            <a:r>
+              <a:rPr lang="en-US" sz="2500" b="1" dirty="0">
+                <a:solidFill>
+                  <a:srgbClr val="F5EDE0"/>
+                </a:solidFill>
+                <a:latin typeface="Palatino Linotype" pitchFamily="34" charset="0"/>
+                <a:ea typeface="Palatino Linotype" pitchFamily="34" charset="-122"/>
+                <a:cs typeface="Palatino Linotype" pitchFamily="34" charset="-120"/>
+              </a:rPr>
+              <a:t>Đ1,382  →  Đ1,121</a:t>
+            </a:r>
+            <a:endParaRPr lang="en-US" sz="2500" dirty="0"/>
+          </a:p>
+        </p:txBody>
+      </p:sp>
+      <p:sp>
+        <p:nvSpPr>
+          <p:cNvPr id="11" name="Text 9"/>
+          <p:cNvSpPr/>
+          <p:nvPr/>
+        </p:nvSpPr>
+        <p:spPr>
+          <a:xfrm>
+            <a:off x="6217920" y="1417320"/>
+            <a:ext cx="5303520" cy="320040"/>
+          </a:xfrm>
+          <a:prstGeom prst="rect">
+            <a:avLst/>
+          </a:prstGeom>
+          <a:noFill/>
+          <a:ln/>
+        </p:spPr>
+        <p:txBody>
+          <a:bodyPr wrap="square" lIns="0" tIns="0" rIns="0" bIns="0" rtlCol="0" anchor="ctr"/>
+          <a:lstStyle/>
+          <a:p>
+            <a:pPr indent="0" marL="0">
+              <a:buNone/>
+            </a:pPr>
+            <a:r>
+              <a:rPr lang="en-US" sz="1400" b="1" spc="300" kern="0" dirty="0">
+                <a:solidFill>
+                  <a:srgbClr val="C9A84C"/>
                 </a:solidFill>
                 <a:latin typeface="Calibri" pitchFamily="34" charset="0"/>
                 <a:ea typeface="Calibri" pitchFamily="34" charset="-122"/>
                 <a:cs typeface="Calibri" pitchFamily="34" charset="-120"/>
               </a:rPr>
-              <a:t>Price per sqft</a:t>
-            </a:r>
-            <a:endParaRPr lang="en-US" sz="1500" dirty="0"/>
-          </a:p>
-        </p:txBody>
-      </p:sp>
-      <p:sp>
-        <p:nvSpPr>
-          <p:cNvPr id="11" name="Shape 9"/>
-          <p:cNvSpPr/>
-          <p:nvPr/>
-        </p:nvSpPr>
-        <p:spPr>
-          <a:xfrm>
-            <a:off x="822960" y="5376672"/>
-            <a:ext cx="3291840" cy="457200"/>
-          </a:xfrm>
-          <a:prstGeom prst="rect">
-            <a:avLst/>
-          </a:prstGeom>
-          <a:solidFill>
-            <a:srgbClr val="C9A84C"/>
-          </a:solidFill>
-          <a:ln/>
-        </p:spPr>
+              <a:t>LOSS</a:t>
+            </a:r>
+            <a:endParaRPr lang="en-US" sz="1400" dirty="0"/>
+          </a:p>
+        </p:txBody>
       </p:sp>
       <p:sp>
         <p:nvSpPr>
@@ -1642,56 +1807,75 @@
         </p:nvSpPr>
         <p:spPr>
           <a:xfrm>
-            <a:off x="6217920" y="1828800"/>
-            <a:ext cx="5303520" cy="320040"/>
-          </a:xfrm>
-          <a:prstGeom prst="rect">
-            <a:avLst/>
-          </a:prstGeom>
-          <a:noFill/>
-          <a:ln/>
-        </p:spPr>
-        <p:txBody>
-          <a:bodyPr wrap="square" lIns="0" tIns="0" rIns="0" bIns="0" rtlCol="0" anchor="ctr"/>
-          <a:lstStyle/>
-          <a:p>
-            <a:pPr indent="0" marL="0">
-              <a:buNone/>
-            </a:pPr>
-            <a:r>
-              <a:rPr lang="en-US" sz="1400" b="1" spc="300" kern="0" dirty="0">
-                <a:solidFill>
-                  <a:srgbClr val="C9A84C"/>
+            <a:off x="6217920" y="1737360"/>
+            <a:ext cx="5669280" cy="914400"/>
+          </a:xfrm>
+          <a:prstGeom prst="rect">
+            <a:avLst/>
+          </a:prstGeom>
+          <a:noFill/>
+          <a:ln/>
+        </p:spPr>
+        <p:txBody>
+          <a:bodyPr wrap="square" lIns="0" tIns="0" rIns="0" bIns="0" rtlCol="0" anchor="ctr"/>
+          <a:lstStyle/>
+          <a:p>
+            <a:pPr indent="0" marL="0">
+              <a:buNone/>
+            </a:pPr>
+            <a:r>
+              <a:rPr lang="en-US" sz="5000" b="1" dirty="0">
+                <a:solidFill>
+                  <a:srgbClr val="E8C96B"/>
+                </a:solidFill>
+                <a:latin typeface="Palatino Linotype" pitchFamily="34" charset="0"/>
+                <a:ea typeface="Palatino Linotype" pitchFamily="34" charset="-122"/>
+                <a:cs typeface="Palatino Linotype" pitchFamily="34" charset="-120"/>
+              </a:rPr>
+              <a:t>−Đ582,860</a:t>
+            </a:r>
+            <a:endParaRPr lang="en-US" sz="5000" dirty="0"/>
+          </a:p>
+        </p:txBody>
+      </p:sp>
+      <p:sp>
+        <p:nvSpPr>
+          <p:cNvPr id="13" name="Text 11"/>
+          <p:cNvSpPr/>
+          <p:nvPr/>
+        </p:nvSpPr>
+        <p:spPr>
+          <a:xfrm>
+            <a:off x="6217920" y="3200400"/>
+            <a:ext cx="3017520" cy="457200"/>
+          </a:xfrm>
+          <a:prstGeom prst="rect">
+            <a:avLst/>
+          </a:prstGeom>
+          <a:noFill/>
+          <a:ln/>
+        </p:spPr>
+        <p:txBody>
+          <a:bodyPr wrap="square" lIns="0" tIns="0" rIns="0" bIns="0" rtlCol="0" anchor="ctr"/>
+          <a:lstStyle/>
+          <a:p>
+            <a:pPr indent="0" marL="0">
+              <a:buNone/>
+            </a:pPr>
+            <a:r>
+              <a:rPr lang="en-US" sz="1600" dirty="0">
+                <a:solidFill>
+                  <a:srgbClr val="8FA898"/>
                 </a:solidFill>
                 <a:latin typeface="Calibri" pitchFamily="34" charset="0"/>
                 <a:ea typeface="Calibri" pitchFamily="34" charset="-122"/>
                 <a:cs typeface="Calibri" pitchFamily="34" charset="-120"/>
               </a:rPr>
-              <a:t>RESULT</a:t>
-            </a:r>
-            <a:endParaRPr lang="en-US" sz="1400" dirty="0"/>
-          </a:p>
-        </p:txBody>
-      </p:sp>
-      <p:sp>
-        <p:nvSpPr>
-          <p:cNvPr id="13" name="Shape 11"/>
-          <p:cNvSpPr/>
-          <p:nvPr/>
-        </p:nvSpPr>
-        <p:spPr>
-          <a:xfrm>
-            <a:off x="6217920" y="2194560"/>
-            <a:ext cx="4206240" cy="868680"/>
-          </a:xfrm>
-          <a:prstGeom prst="rect">
-            <a:avLst/>
-          </a:prstGeom>
-          <a:solidFill>
-            <a:srgbClr val="E8C96B"/>
-          </a:solidFill>
-          <a:ln/>
-        </p:spPr>
+              <a:t>ROI on full price</a:t>
+            </a:r>
+            <a:endParaRPr lang="en-US" sz="1600" dirty="0"/>
+          </a:p>
+        </p:txBody>
       </p:sp>
       <p:sp>
         <p:nvSpPr>
@@ -1701,7 +1885,46 @@
         </p:nvSpPr>
         <p:spPr>
           <a:xfrm>
-            <a:off x="6217920" y="3520440"/>
+            <a:off x="9235440" y="3108960"/>
+            <a:ext cx="2651760" cy="548640"/>
+          </a:xfrm>
+          <a:prstGeom prst="rect">
+            <a:avLst/>
+          </a:prstGeom>
+          <a:noFill/>
+          <a:ln/>
+        </p:spPr>
+        <p:txBody>
+          <a:bodyPr wrap="square" lIns="0" tIns="0" rIns="0" bIns="0" rtlCol="0" anchor="ctr"/>
+          <a:lstStyle/>
+          <a:p>
+            <a:pPr indent="0" marL="0">
+              <a:buNone/>
+            </a:pPr>
+            <a:r>
+              <a:rPr lang="en-US" sz="2800" b="1" dirty="0">
+                <a:solidFill>
+                  <a:srgbClr val="F5EDE0"/>
+                </a:solidFill>
+                <a:latin typeface="Palatino Linotype" pitchFamily="34" charset="0"/>
+                <a:ea typeface="Palatino Linotype" pitchFamily="34" charset="-122"/>
+                <a:cs typeface="Palatino Linotype" pitchFamily="34" charset="-120"/>
+              </a:rPr>
+              <a:t>−18.9%</a:t>
+            </a:r>
+            <a:endParaRPr lang="en-US" sz="2800" dirty="0"/>
+          </a:p>
+        </p:txBody>
+      </p:sp>
+      <p:sp>
+        <p:nvSpPr>
+          <p:cNvPr id="15" name="Text 13"/>
+          <p:cNvSpPr/>
+          <p:nvPr/>
+        </p:nvSpPr>
+        <p:spPr>
+          <a:xfrm>
+            <a:off x="6217920" y="4069080"/>
             <a:ext cx="3017520" cy="457200"/>
           </a:xfrm>
           <a:prstGeom prst="rect">
@@ -1726,7 +1949,7 @@
                 <a:ea typeface="Calibri" pitchFamily="34" charset="-122"/>
                 <a:cs typeface="Calibri" pitchFamily="34" charset="-120"/>
               </a:rPr>
-              <a:t>ROI on full price</a:t>
+              <a:t>ROE on cash in</a:t>
             </a:r>
             <a:endParaRPr lang="en-US" sz="1600" dirty="0"/>
           </a:p>
@@ -1734,33 +1957,52 @@
       </p:sp>
       <p:sp>
         <p:nvSpPr>
-          <p:cNvPr id="15" name="Shape 13"/>
-          <p:cNvSpPr/>
-          <p:nvPr/>
-        </p:nvSpPr>
-        <p:spPr>
-          <a:xfrm>
-            <a:off x="9235440" y="3474720"/>
-            <a:ext cx="2011680" cy="457200"/>
-          </a:xfrm>
-          <a:prstGeom prst="rect">
-            <a:avLst/>
-          </a:prstGeom>
-          <a:solidFill>
-            <a:srgbClr val="C9A84C"/>
-          </a:solidFill>
-          <a:ln/>
-        </p:spPr>
-      </p:sp>
-      <p:sp>
-        <p:nvSpPr>
           <p:cNvPr id="16" name="Text 14"/>
           <p:cNvSpPr/>
           <p:nvPr/>
         </p:nvSpPr>
         <p:spPr>
           <a:xfrm>
-            <a:off x="6217920" y="4361688"/>
+            <a:off x="9235440" y="3977640"/>
+            <a:ext cx="2651760" cy="548640"/>
+          </a:xfrm>
+          <a:prstGeom prst="rect">
+            <a:avLst/>
+          </a:prstGeom>
+          <a:noFill/>
+          <a:ln/>
+        </p:spPr>
+        <p:txBody>
+          <a:bodyPr wrap="square" lIns="0" tIns="0" rIns="0" bIns="0" rtlCol="0" anchor="ctr"/>
+          <a:lstStyle/>
+          <a:p>
+            <a:pPr indent="0" marL="0">
+              <a:buNone/>
+            </a:pPr>
+            <a:r>
+              <a:rPr lang="en-US" sz="2800" b="1" dirty="0">
+                <a:solidFill>
+                  <a:srgbClr val="F5EDE0"/>
+                </a:solidFill>
+                <a:latin typeface="Palatino Linotype" pitchFamily="34" charset="0"/>
+                <a:ea typeface="Palatino Linotype" pitchFamily="34" charset="-122"/>
+                <a:cs typeface="Palatino Linotype" pitchFamily="34" charset="-120"/>
+              </a:rPr>
+              <a:t>−18.9%</a:t>
+            </a:r>
+            <a:endParaRPr lang="en-US" sz="2800" dirty="0"/>
+          </a:p>
+        </p:txBody>
+      </p:sp>
+      <p:sp>
+        <p:nvSpPr>
+          <p:cNvPr id="17" name="Text 15"/>
+          <p:cNvSpPr/>
+          <p:nvPr/>
+        </p:nvSpPr>
+        <p:spPr>
+          <a:xfrm>
+            <a:off x="6217920" y="4937760"/>
             <a:ext cx="3017520" cy="457200"/>
           </a:xfrm>
           <a:prstGeom prst="rect">
@@ -1793,119 +2035,79 @@
       </p:sp>
       <p:sp>
         <p:nvSpPr>
-          <p:cNvPr id="17" name="Shape 15"/>
-          <p:cNvSpPr/>
-          <p:nvPr/>
-        </p:nvSpPr>
-        <p:spPr>
-          <a:xfrm>
-            <a:off x="9235440" y="4315968"/>
-            <a:ext cx="2011680" cy="457200"/>
-          </a:xfrm>
-          <a:prstGeom prst="rect">
-            <a:avLst/>
-          </a:prstGeom>
-          <a:solidFill>
-            <a:srgbClr val="C9A84C"/>
-          </a:solidFill>
-          <a:ln/>
-        </p:spPr>
-      </p:sp>
-      <p:sp>
-        <p:nvSpPr>
           <p:cNvPr id="18" name="Text 16"/>
           <p:cNvSpPr/>
           <p:nvPr/>
         </p:nvSpPr>
         <p:spPr>
           <a:xfrm>
-            <a:off x="6217920" y="5202936"/>
-            <a:ext cx="3017520" cy="457200"/>
-          </a:xfrm>
-          <a:prstGeom prst="rect">
-            <a:avLst/>
-          </a:prstGeom>
-          <a:noFill/>
-          <a:ln/>
-        </p:spPr>
-        <p:txBody>
-          <a:bodyPr wrap="square" lIns="0" tIns="0" rIns="0" bIns="0" rtlCol="0" anchor="ctr"/>
-          <a:lstStyle/>
-          <a:p>
-            <a:pPr indent="0" marL="0">
-              <a:buNone/>
-            </a:pPr>
-            <a:r>
-              <a:rPr lang="en-US" sz="1600" dirty="0">
-                <a:solidFill>
-                  <a:srgbClr val="8FA898"/>
-                </a:solidFill>
-                <a:latin typeface="Calibri" pitchFamily="34" charset="0"/>
-                <a:ea typeface="Calibri" pitchFamily="34" charset="-122"/>
-                <a:cs typeface="Calibri" pitchFamily="34" charset="-120"/>
-              </a:rPr>
-              <a:t>Cost per month held</a:t>
-            </a:r>
-            <a:endParaRPr lang="en-US" sz="1600" dirty="0"/>
-          </a:p>
-        </p:txBody>
-      </p:sp>
-      <p:sp>
-        <p:nvSpPr>
-          <p:cNvPr id="19" name="Shape 17"/>
-          <p:cNvSpPr/>
-          <p:nvPr/>
-        </p:nvSpPr>
-        <p:spPr>
-          <a:xfrm>
-            <a:off x="9235440" y="5157216"/>
-            <a:ext cx="2011680" cy="457200"/>
-          </a:xfrm>
-          <a:prstGeom prst="rect">
-            <a:avLst/>
-          </a:prstGeom>
-          <a:solidFill>
-            <a:srgbClr val="C9A84C"/>
-          </a:solidFill>
-          <a:ln/>
-        </p:spPr>
-      </p:sp>
-      <p:sp>
-        <p:nvSpPr>
-          <p:cNvPr id="20" name="Text 18"/>
-          <p:cNvSpPr/>
-          <p:nvPr/>
-        </p:nvSpPr>
-        <p:spPr>
-          <a:xfrm>
-            <a:off x="0" y="6035040"/>
-            <a:ext cx="12188952" cy="411480"/>
-          </a:xfrm>
-          <a:prstGeom prst="rect">
-            <a:avLst/>
-          </a:prstGeom>
-          <a:noFill/>
-          <a:ln/>
-        </p:spPr>
-        <p:txBody>
-          <a:bodyPr wrap="square" lIns="0" tIns="0" rIns="0" bIns="0" rtlCol="0" anchor="ctr"/>
-          <a:lstStyle/>
-          <a:p>
-            <a:pPr algn="ctr" indent="0" marL="0">
-              <a:buNone/>
-            </a:pPr>
-            <a:r>
-              <a:rPr lang="en-US" sz="1900" dirty="0">
-                <a:solidFill>
-                  <a:srgbClr val="C9A84C"/>
+            <a:off x="9235440" y="4846320"/>
+            <a:ext cx="2651760" cy="548640"/>
+          </a:xfrm>
+          <a:prstGeom prst="rect">
+            <a:avLst/>
+          </a:prstGeom>
+          <a:noFill/>
+          <a:ln/>
+        </p:spPr>
+        <p:txBody>
+          <a:bodyPr wrap="square" lIns="0" tIns="0" rIns="0" bIns="0" rtlCol="0" anchor="ctr"/>
+          <a:lstStyle/>
+          <a:p>
+            <a:pPr indent="0" marL="0">
+              <a:buNone/>
+            </a:pPr>
+            <a:r>
+              <a:rPr lang="en-US" sz="2800" b="1" dirty="0">
+                <a:solidFill>
+                  <a:srgbClr val="F5EDE0"/>
                 </a:solidFill>
                 <a:latin typeface="Palatino Linotype" pitchFamily="34" charset="0"/>
                 <a:ea typeface="Palatino Linotype" pitchFamily="34" charset="-122"/>
                 <a:cs typeface="Palatino Linotype" pitchFamily="34" charset="-120"/>
               </a:rPr>
-              <a:t>A real unit · a real transaction record · DAMAC Lagoons</a:t>
-            </a:r>
-            <a:endParaRPr lang="en-US" sz="1900" dirty="0"/>
+              <a:t>−11.3% / yr</a:t>
+            </a:r>
+            <a:endParaRPr lang="en-US" sz="2800" dirty="0"/>
+          </a:p>
+        </p:txBody>
+      </p:sp>
+      <p:sp>
+        <p:nvSpPr>
+          <p:cNvPr id="19" name="Text 17"/>
+          <p:cNvSpPr/>
+          <p:nvPr/>
+        </p:nvSpPr>
+        <p:spPr>
+          <a:xfrm>
+            <a:off x="0" y="6035040"/>
+            <a:ext cx="12188952" cy="411480"/>
+          </a:xfrm>
+          <a:prstGeom prst="rect">
+            <a:avLst/>
+          </a:prstGeom>
+          <a:noFill/>
+          <a:ln/>
+        </p:spPr>
+        <p:txBody>
+          <a:bodyPr wrap="square" lIns="0" tIns="0" rIns="0" bIns="0" rtlCol="0" anchor="ctr"/>
+          <a:lstStyle/>
+          <a:p>
+            <a:pPr algn="ctr" indent="0" marL="0">
+              <a:buNone/>
+            </a:pPr>
+            <a:r>
+              <a:rPr lang="en-US" sz="1800" dirty="0">
+                <a:solidFill>
+                  <a:srgbClr val="C9A84C"/>
+                </a:solidFill>
+                <a:latin typeface="Palatino Linotype" pitchFamily="34" charset="0"/>
+                <a:ea typeface="Palatino Linotype" pitchFamily="34" charset="-122"/>
+                <a:cs typeface="Palatino Linotype" pitchFamily="34" charset="-120"/>
+              </a:rPr>
+              <a:t>Đ27,755 lost for every month held - bought at the developer’s 2024 release price</a:t>
+            </a:r>
+            <a:endParaRPr lang="en-US" sz="1800" dirty="0"/>
           </a:p>
         </p:txBody>
       </p:sp>
@@ -2131,7 +2333,7 @@
       </p:grpSpPr>
       <p:pic>
         <p:nvPicPr>
-          <p:cNvPr id="2" name="Image 0" descr="record_redacted.png">    </p:cNvPr>
+          <p:cNvPr id="2" name="Image 0" descr="record_resale_covered.png">    </p:cNvPr>
           <p:cNvPicPr>
             <a:picLocks noChangeAspect="1"/>
           </p:cNvPicPr>
@@ -2245,7 +2447,7 @@
     <p:bg>
       <p:bgPr>
         <a:solidFill>
-          <a:srgbClr val="152A1F"/>
+          <a:srgbClr val="111111"/>
         </a:solidFill>
       </p:bgPr>
     </p:bg>
@@ -2263,15 +2465,39 @@
           <a:chExt cx="0" cy="0"/>
         </a:xfrm>
       </p:grpSpPr>
-      <p:sp>
-        <p:nvSpPr>
-          <p:cNvPr id="2" name="Text 0"/>
-          <p:cNvSpPr/>
-          <p:nvPr/>
-        </p:nvSpPr>
-        <p:spPr>
-          <a:xfrm>
-            <a:off x="0" y="384048"/>
+      <p:pic>
+        <p:nvPicPr>
+          <p:cNvPr id="2" name="Image 0" descr="record_redacted.png">    </p:cNvPr>
+          <p:cNvPicPr>
+            <a:picLocks noChangeAspect="1"/>
+          </p:cNvPicPr>
+          <p:nvPr/>
+        </p:nvPicPr>
+        <p:blipFill>
+          <a:blip r:embed="rId1"/>
+          <a:stretch>
+            <a:fillRect/>
+          </a:stretch>
+        </p:blipFill>
+        <p:spPr>
+          <a:xfrm>
+            <a:off x="516636" y="-29644"/>
+            <a:ext cx="11155680" cy="7283048"/>
+          </a:xfrm>
+          <a:prstGeom prst="rect">
+            <a:avLst/>
+          </a:prstGeom>
+        </p:spPr>
+      </p:pic>
+      <p:sp>
+        <p:nvSpPr>
+          <p:cNvPr id="3" name="Text 0"/>
+          <p:cNvSpPr/>
+          <p:nvPr/>
+        </p:nvSpPr>
+        <p:spPr>
+          <a:xfrm>
+            <a:off x="0" y="228600"/>
             <a:ext cx="12188952" cy="320040"/>
           </a:xfrm>
           <a:prstGeom prst="rect">
@@ -2288,30 +2514,30 @@
               <a:buNone/>
             </a:pPr>
             <a:r>
-              <a:rPr lang="en-US" sz="1300" b="1" spc="400" kern="0" dirty="0">
-                <a:solidFill>
-                  <a:srgbClr val="C9A84C"/>
+              <a:rPr lang="en-US" sz="1500" b="1" spc="300" kern="0" dirty="0">
+                <a:solidFill>
+                  <a:srgbClr val="E8C96B"/>
                 </a:solidFill>
                 <a:latin typeface="Calibri" pitchFamily="34" charset="0"/>
                 <a:ea typeface="Calibri" pitchFamily="34" charset="-122"/>
                 <a:cs typeface="Calibri" pitchFamily="34" charset="-120"/>
               </a:rPr>
-              <a:t>THE MATHS</a:t>
-            </a:r>
-            <a:endParaRPr lang="en-US" sz="1300" dirty="0"/>
-          </a:p>
-        </p:txBody>
-      </p:sp>
-      <p:sp>
-        <p:nvSpPr>
-          <p:cNvPr id="3" name="Text 1"/>
-          <p:cNvSpPr/>
-          <p:nvPr/>
-        </p:nvSpPr>
-        <p:spPr>
-          <a:xfrm>
-            <a:off x="11000232" y="384048"/>
-            <a:ext cx="640080" cy="320040"/>
+              <a:t>THE ACTUAL TRANSACTION RECORD</a:t>
+            </a:r>
+            <a:endParaRPr lang="en-US" sz="1500" dirty="0"/>
+          </a:p>
+        </p:txBody>
+      </p:sp>
+      <p:sp>
+        <p:nvSpPr>
+          <p:cNvPr id="4" name="Text 1"/>
+          <p:cNvSpPr/>
+          <p:nvPr/>
+        </p:nvSpPr>
+        <p:spPr>
+          <a:xfrm>
+            <a:off x="11274552" y="228600"/>
+            <a:ext cx="548640" cy="320040"/>
           </a:xfrm>
           <a:prstGeom prst="rect">
             <a:avLst/>
@@ -2338,669 +2564,6 @@
               <a:t>04</a:t>
             </a:r>
             <a:endParaRPr lang="en-US" sz="1200" dirty="0"/>
-          </a:p>
-        </p:txBody>
-      </p:sp>
-      <p:sp>
-        <p:nvSpPr>
-          <p:cNvPr id="4" name="Text 2"/>
-          <p:cNvSpPr/>
-          <p:nvPr/>
-        </p:nvSpPr>
-        <p:spPr>
-          <a:xfrm>
-            <a:off x="822960" y="1463040"/>
-            <a:ext cx="4754880" cy="365760"/>
-          </a:xfrm>
-          <a:prstGeom prst="rect">
-            <a:avLst/>
-          </a:prstGeom>
-          <a:noFill/>
-          <a:ln/>
-        </p:spPr>
-        <p:txBody>
-          <a:bodyPr wrap="square" lIns="0" tIns="0" rIns="0" bIns="0" rtlCol="0" anchor="ctr"/>
-          <a:lstStyle/>
-          <a:p>
-            <a:pPr indent="0" marL="0">
-              <a:buNone/>
-            </a:pPr>
-            <a:r>
-              <a:rPr lang="en-US" sz="1500" dirty="0">
-                <a:solidFill>
-                  <a:srgbClr val="8FA898"/>
-                </a:solidFill>
-                <a:latin typeface="Calibri" pitchFamily="34" charset="0"/>
-                <a:ea typeface="Calibri" pitchFamily="34" charset="-122"/>
-                <a:cs typeface="Calibri" pitchFamily="34" charset="-120"/>
-              </a:rPr>
-              <a:t>Bought from the developer</a:t>
-            </a:r>
-            <a:endParaRPr lang="en-US" sz="1500" dirty="0"/>
-          </a:p>
-        </p:txBody>
-      </p:sp>
-      <p:sp>
-        <p:nvSpPr>
-          <p:cNvPr id="5" name="Text 3"/>
-          <p:cNvSpPr/>
-          <p:nvPr/>
-        </p:nvSpPr>
-        <p:spPr>
-          <a:xfrm>
-            <a:off x="822960" y="1810512"/>
-            <a:ext cx="4937760" cy="502920"/>
-          </a:xfrm>
-          <a:prstGeom prst="rect">
-            <a:avLst/>
-          </a:prstGeom>
-          <a:noFill/>
-          <a:ln/>
-        </p:spPr>
-        <p:txBody>
-          <a:bodyPr wrap="square" lIns="0" tIns="0" rIns="0" bIns="0" rtlCol="0" anchor="ctr"/>
-          <a:lstStyle/>
-          <a:p>
-            <a:pPr indent="0" marL="0">
-              <a:buNone/>
-            </a:pPr>
-            <a:r>
-              <a:rPr lang="en-US" sz="2500" b="1" dirty="0">
-                <a:solidFill>
-                  <a:srgbClr val="F5EDE0"/>
-                </a:solidFill>
-                <a:latin typeface="Palatino Linotype" pitchFamily="34" charset="0"/>
-                <a:ea typeface="Palatino Linotype" pitchFamily="34" charset="-122"/>
-                <a:cs typeface="Palatino Linotype" pitchFamily="34" charset="-120"/>
-              </a:rPr>
-              <a:t>Đ3,082,860  ·  Sep 2024</a:t>
-            </a:r>
-            <a:endParaRPr lang="en-US" sz="2500" dirty="0"/>
-          </a:p>
-        </p:txBody>
-      </p:sp>
-      <p:sp>
-        <p:nvSpPr>
-          <p:cNvPr id="6" name="Text 4"/>
-          <p:cNvSpPr/>
-          <p:nvPr/>
-        </p:nvSpPr>
-        <p:spPr>
-          <a:xfrm>
-            <a:off x="822960" y="2514600"/>
-            <a:ext cx="4754880" cy="365760"/>
-          </a:xfrm>
-          <a:prstGeom prst="rect">
-            <a:avLst/>
-          </a:prstGeom>
-          <a:noFill/>
-          <a:ln/>
-        </p:spPr>
-        <p:txBody>
-          <a:bodyPr wrap="square" lIns="0" tIns="0" rIns="0" bIns="0" rtlCol="0" anchor="ctr"/>
-          <a:lstStyle/>
-          <a:p>
-            <a:pPr indent="0" marL="0">
-              <a:buNone/>
-            </a:pPr>
-            <a:r>
-              <a:rPr lang="en-US" sz="1500" dirty="0">
-                <a:solidFill>
-                  <a:srgbClr val="8FA898"/>
-                </a:solidFill>
-                <a:latin typeface="Calibri" pitchFamily="34" charset="0"/>
-                <a:ea typeface="Calibri" pitchFamily="34" charset="-122"/>
-                <a:cs typeface="Calibri" pitchFamily="34" charset="-120"/>
-              </a:rPr>
-              <a:t>Sold</a:t>
-            </a:r>
-            <a:endParaRPr lang="en-US" sz="1500" dirty="0"/>
-          </a:p>
-        </p:txBody>
-      </p:sp>
-      <p:sp>
-        <p:nvSpPr>
-          <p:cNvPr id="7" name="Text 5"/>
-          <p:cNvSpPr/>
-          <p:nvPr/>
-        </p:nvSpPr>
-        <p:spPr>
-          <a:xfrm>
-            <a:off x="822960" y="2862072"/>
-            <a:ext cx="4937760" cy="502920"/>
-          </a:xfrm>
-          <a:prstGeom prst="rect">
-            <a:avLst/>
-          </a:prstGeom>
-          <a:noFill/>
-          <a:ln/>
-        </p:spPr>
-        <p:txBody>
-          <a:bodyPr wrap="square" lIns="0" tIns="0" rIns="0" bIns="0" rtlCol="0" anchor="ctr"/>
-          <a:lstStyle/>
-          <a:p>
-            <a:pPr indent="0" marL="0">
-              <a:buNone/>
-            </a:pPr>
-            <a:r>
-              <a:rPr lang="en-US" sz="2500" b="1" dirty="0">
-                <a:solidFill>
-                  <a:srgbClr val="F5EDE0"/>
-                </a:solidFill>
-                <a:latin typeface="Palatino Linotype" pitchFamily="34" charset="0"/>
-                <a:ea typeface="Palatino Linotype" pitchFamily="34" charset="-122"/>
-                <a:cs typeface="Palatino Linotype" pitchFamily="34" charset="-120"/>
-              </a:rPr>
-              <a:t>Đ2,500,000  ·  Jun 2026</a:t>
-            </a:r>
-            <a:endParaRPr lang="en-US" sz="2500" dirty="0"/>
-          </a:p>
-        </p:txBody>
-      </p:sp>
-      <p:sp>
-        <p:nvSpPr>
-          <p:cNvPr id="8" name="Text 6"/>
-          <p:cNvSpPr/>
-          <p:nvPr/>
-        </p:nvSpPr>
-        <p:spPr>
-          <a:xfrm>
-            <a:off x="822960" y="3566160"/>
-            <a:ext cx="4754880" cy="365760"/>
-          </a:xfrm>
-          <a:prstGeom prst="rect">
-            <a:avLst/>
-          </a:prstGeom>
-          <a:noFill/>
-          <a:ln/>
-        </p:spPr>
-        <p:txBody>
-          <a:bodyPr wrap="square" lIns="0" tIns="0" rIns="0" bIns="0" rtlCol="0" anchor="ctr"/>
-          <a:lstStyle/>
-          <a:p>
-            <a:pPr indent="0" marL="0">
-              <a:buNone/>
-            </a:pPr>
-            <a:r>
-              <a:rPr lang="en-US" sz="1500" dirty="0">
-                <a:solidFill>
-                  <a:srgbClr val="8FA898"/>
-                </a:solidFill>
-                <a:latin typeface="Calibri" pitchFamily="34" charset="0"/>
-                <a:ea typeface="Calibri" pitchFamily="34" charset="-122"/>
-                <a:cs typeface="Calibri" pitchFamily="34" charset="-120"/>
-              </a:rPr>
-              <a:t>Time held</a:t>
-            </a:r>
-            <a:endParaRPr lang="en-US" sz="1500" dirty="0"/>
-          </a:p>
-        </p:txBody>
-      </p:sp>
-      <p:sp>
-        <p:nvSpPr>
-          <p:cNvPr id="9" name="Text 7"/>
-          <p:cNvSpPr/>
-          <p:nvPr/>
-        </p:nvSpPr>
-        <p:spPr>
-          <a:xfrm>
-            <a:off x="822960" y="3913632"/>
-            <a:ext cx="4937760" cy="502920"/>
-          </a:xfrm>
-          <a:prstGeom prst="rect">
-            <a:avLst/>
-          </a:prstGeom>
-          <a:noFill/>
-          <a:ln/>
-        </p:spPr>
-        <p:txBody>
-          <a:bodyPr wrap="square" lIns="0" tIns="0" rIns="0" bIns="0" rtlCol="0" anchor="ctr"/>
-          <a:lstStyle/>
-          <a:p>
-            <a:pPr indent="0" marL="0">
-              <a:buNone/>
-            </a:pPr>
-            <a:r>
-              <a:rPr lang="en-US" sz="2500" b="1" dirty="0">
-                <a:solidFill>
-                  <a:srgbClr val="F5EDE0"/>
-                </a:solidFill>
-                <a:latin typeface="Palatino Linotype" pitchFamily="34" charset="0"/>
-                <a:ea typeface="Palatino Linotype" pitchFamily="34" charset="-122"/>
-                <a:cs typeface="Palatino Linotype" pitchFamily="34" charset="-120"/>
-              </a:rPr>
-              <a:t>21 months</a:t>
-            </a:r>
-            <a:endParaRPr lang="en-US" sz="2500" dirty="0"/>
-          </a:p>
-        </p:txBody>
-      </p:sp>
-      <p:sp>
-        <p:nvSpPr>
-          <p:cNvPr id="10" name="Text 8"/>
-          <p:cNvSpPr/>
-          <p:nvPr/>
-        </p:nvSpPr>
-        <p:spPr>
-          <a:xfrm>
-            <a:off x="822960" y="4617720"/>
-            <a:ext cx="4754880" cy="365760"/>
-          </a:xfrm>
-          <a:prstGeom prst="rect">
-            <a:avLst/>
-          </a:prstGeom>
-          <a:noFill/>
-          <a:ln/>
-        </p:spPr>
-        <p:txBody>
-          <a:bodyPr wrap="square" lIns="0" tIns="0" rIns="0" bIns="0" rtlCol="0" anchor="ctr"/>
-          <a:lstStyle/>
-          <a:p>
-            <a:pPr indent="0" marL="0">
-              <a:buNone/>
-            </a:pPr>
-            <a:r>
-              <a:rPr lang="en-US" sz="1500" dirty="0">
-                <a:solidFill>
-                  <a:srgbClr val="8FA898"/>
-                </a:solidFill>
-                <a:latin typeface="Calibri" pitchFamily="34" charset="0"/>
-                <a:ea typeface="Calibri" pitchFamily="34" charset="-122"/>
-                <a:cs typeface="Calibri" pitchFamily="34" charset="-120"/>
-              </a:rPr>
-              <a:t>Price per sqft</a:t>
-            </a:r>
-            <a:endParaRPr lang="en-US" sz="1500" dirty="0"/>
-          </a:p>
-        </p:txBody>
-      </p:sp>
-      <p:sp>
-        <p:nvSpPr>
-          <p:cNvPr id="11" name="Text 9"/>
-          <p:cNvSpPr/>
-          <p:nvPr/>
-        </p:nvSpPr>
-        <p:spPr>
-          <a:xfrm>
-            <a:off x="822960" y="4965192"/>
-            <a:ext cx="4937760" cy="502920"/>
-          </a:xfrm>
-          <a:prstGeom prst="rect">
-            <a:avLst/>
-          </a:prstGeom>
-          <a:noFill/>
-          <a:ln/>
-        </p:spPr>
-        <p:txBody>
-          <a:bodyPr wrap="square" lIns="0" tIns="0" rIns="0" bIns="0" rtlCol="0" anchor="ctr"/>
-          <a:lstStyle/>
-          <a:p>
-            <a:pPr indent="0" marL="0">
-              <a:buNone/>
-            </a:pPr>
-            <a:r>
-              <a:rPr lang="en-US" sz="2500" b="1" dirty="0">
-                <a:solidFill>
-                  <a:srgbClr val="F5EDE0"/>
-                </a:solidFill>
-                <a:latin typeface="Palatino Linotype" pitchFamily="34" charset="0"/>
-                <a:ea typeface="Palatino Linotype" pitchFamily="34" charset="-122"/>
-                <a:cs typeface="Palatino Linotype" pitchFamily="34" charset="-120"/>
-              </a:rPr>
-              <a:t>Đ1,382  →  Đ1,121</a:t>
-            </a:r>
-            <a:endParaRPr lang="en-US" sz="2500" dirty="0"/>
-          </a:p>
-        </p:txBody>
-      </p:sp>
-      <p:sp>
-        <p:nvSpPr>
-          <p:cNvPr id="12" name="Text 10"/>
-          <p:cNvSpPr/>
-          <p:nvPr/>
-        </p:nvSpPr>
-        <p:spPr>
-          <a:xfrm>
-            <a:off x="6217920" y="1417320"/>
-            <a:ext cx="5303520" cy="320040"/>
-          </a:xfrm>
-          <a:prstGeom prst="rect">
-            <a:avLst/>
-          </a:prstGeom>
-          <a:noFill/>
-          <a:ln/>
-        </p:spPr>
-        <p:txBody>
-          <a:bodyPr wrap="square" lIns="0" tIns="0" rIns="0" bIns="0" rtlCol="0" anchor="ctr"/>
-          <a:lstStyle/>
-          <a:p>
-            <a:pPr indent="0" marL="0">
-              <a:buNone/>
-            </a:pPr>
-            <a:r>
-              <a:rPr lang="en-US" sz="1400" b="1" spc="300" kern="0" dirty="0">
-                <a:solidFill>
-                  <a:srgbClr val="C9A84C"/>
-                </a:solidFill>
-                <a:latin typeface="Calibri" pitchFamily="34" charset="0"/>
-                <a:ea typeface="Calibri" pitchFamily="34" charset="-122"/>
-                <a:cs typeface="Calibri" pitchFamily="34" charset="-120"/>
-              </a:rPr>
-              <a:t>LOSS</a:t>
-            </a:r>
-            <a:endParaRPr lang="en-US" sz="1400" dirty="0"/>
-          </a:p>
-        </p:txBody>
-      </p:sp>
-      <p:sp>
-        <p:nvSpPr>
-          <p:cNvPr id="13" name="Text 11"/>
-          <p:cNvSpPr/>
-          <p:nvPr/>
-        </p:nvSpPr>
-        <p:spPr>
-          <a:xfrm>
-            <a:off x="6217920" y="1737360"/>
-            <a:ext cx="5669280" cy="914400"/>
-          </a:xfrm>
-          <a:prstGeom prst="rect">
-            <a:avLst/>
-          </a:prstGeom>
-          <a:noFill/>
-          <a:ln/>
-        </p:spPr>
-        <p:txBody>
-          <a:bodyPr wrap="square" lIns="0" tIns="0" rIns="0" bIns="0" rtlCol="0" anchor="ctr"/>
-          <a:lstStyle/>
-          <a:p>
-            <a:pPr indent="0" marL="0">
-              <a:buNone/>
-            </a:pPr>
-            <a:r>
-              <a:rPr lang="en-US" sz="5000" b="1" dirty="0">
-                <a:solidFill>
-                  <a:srgbClr val="E8C96B"/>
-                </a:solidFill>
-                <a:latin typeface="Palatino Linotype" pitchFamily="34" charset="0"/>
-                <a:ea typeface="Palatino Linotype" pitchFamily="34" charset="-122"/>
-                <a:cs typeface="Palatino Linotype" pitchFamily="34" charset="-120"/>
-              </a:rPr>
-              <a:t>−Đ582,860</a:t>
-            </a:r>
-            <a:endParaRPr lang="en-US" sz="5000" dirty="0"/>
-          </a:p>
-        </p:txBody>
-      </p:sp>
-      <p:sp>
-        <p:nvSpPr>
-          <p:cNvPr id="14" name="Text 12"/>
-          <p:cNvSpPr/>
-          <p:nvPr/>
-        </p:nvSpPr>
-        <p:spPr>
-          <a:xfrm>
-            <a:off x="6217920" y="3200400"/>
-            <a:ext cx="3017520" cy="457200"/>
-          </a:xfrm>
-          <a:prstGeom prst="rect">
-            <a:avLst/>
-          </a:prstGeom>
-          <a:noFill/>
-          <a:ln/>
-        </p:spPr>
-        <p:txBody>
-          <a:bodyPr wrap="square" lIns="0" tIns="0" rIns="0" bIns="0" rtlCol="0" anchor="ctr"/>
-          <a:lstStyle/>
-          <a:p>
-            <a:pPr indent="0" marL="0">
-              <a:buNone/>
-            </a:pPr>
-            <a:r>
-              <a:rPr lang="en-US" sz="1600" dirty="0">
-                <a:solidFill>
-                  <a:srgbClr val="8FA898"/>
-                </a:solidFill>
-                <a:latin typeface="Calibri" pitchFamily="34" charset="0"/>
-                <a:ea typeface="Calibri" pitchFamily="34" charset="-122"/>
-                <a:cs typeface="Calibri" pitchFamily="34" charset="-120"/>
-              </a:rPr>
-              <a:t>ROI on full price</a:t>
-            </a:r>
-            <a:endParaRPr lang="en-US" sz="1600" dirty="0"/>
-          </a:p>
-        </p:txBody>
-      </p:sp>
-      <p:sp>
-        <p:nvSpPr>
-          <p:cNvPr id="15" name="Text 13"/>
-          <p:cNvSpPr/>
-          <p:nvPr/>
-        </p:nvSpPr>
-        <p:spPr>
-          <a:xfrm>
-            <a:off x="9235440" y="3108960"/>
-            <a:ext cx="2651760" cy="548640"/>
-          </a:xfrm>
-          <a:prstGeom prst="rect">
-            <a:avLst/>
-          </a:prstGeom>
-          <a:noFill/>
-          <a:ln/>
-        </p:spPr>
-        <p:txBody>
-          <a:bodyPr wrap="square" lIns="0" tIns="0" rIns="0" bIns="0" rtlCol="0" anchor="ctr"/>
-          <a:lstStyle/>
-          <a:p>
-            <a:pPr indent="0" marL="0">
-              <a:buNone/>
-            </a:pPr>
-            <a:r>
-              <a:rPr lang="en-US" sz="2800" b="1" dirty="0">
-                <a:solidFill>
-                  <a:srgbClr val="F5EDE0"/>
-                </a:solidFill>
-                <a:latin typeface="Palatino Linotype" pitchFamily="34" charset="0"/>
-                <a:ea typeface="Palatino Linotype" pitchFamily="34" charset="-122"/>
-                <a:cs typeface="Palatino Linotype" pitchFamily="34" charset="-120"/>
-              </a:rPr>
-              <a:t>−18.9%</a:t>
-            </a:r>
-            <a:endParaRPr lang="en-US" sz="2800" dirty="0"/>
-          </a:p>
-        </p:txBody>
-      </p:sp>
-      <p:sp>
-        <p:nvSpPr>
-          <p:cNvPr id="16" name="Text 14"/>
-          <p:cNvSpPr/>
-          <p:nvPr/>
-        </p:nvSpPr>
-        <p:spPr>
-          <a:xfrm>
-            <a:off x="6217920" y="4069080"/>
-            <a:ext cx="3017520" cy="457200"/>
-          </a:xfrm>
-          <a:prstGeom prst="rect">
-            <a:avLst/>
-          </a:prstGeom>
-          <a:noFill/>
-          <a:ln/>
-        </p:spPr>
-        <p:txBody>
-          <a:bodyPr wrap="square" lIns="0" tIns="0" rIns="0" bIns="0" rtlCol="0" anchor="ctr"/>
-          <a:lstStyle/>
-          <a:p>
-            <a:pPr indent="0" marL="0">
-              <a:buNone/>
-            </a:pPr>
-            <a:r>
-              <a:rPr lang="en-US" sz="1600" dirty="0">
-                <a:solidFill>
-                  <a:srgbClr val="8FA898"/>
-                </a:solidFill>
-                <a:latin typeface="Calibri" pitchFamily="34" charset="0"/>
-                <a:ea typeface="Calibri" pitchFamily="34" charset="-122"/>
-                <a:cs typeface="Calibri" pitchFamily="34" charset="-120"/>
-              </a:rPr>
-              <a:t>IRR (annualised)</a:t>
-            </a:r>
-            <a:endParaRPr lang="en-US" sz="1600" dirty="0"/>
-          </a:p>
-        </p:txBody>
-      </p:sp>
-      <p:sp>
-        <p:nvSpPr>
-          <p:cNvPr id="17" name="Text 15"/>
-          <p:cNvSpPr/>
-          <p:nvPr/>
-        </p:nvSpPr>
-        <p:spPr>
-          <a:xfrm>
-            <a:off x="9235440" y="3977640"/>
-            <a:ext cx="2651760" cy="548640"/>
-          </a:xfrm>
-          <a:prstGeom prst="rect">
-            <a:avLst/>
-          </a:prstGeom>
-          <a:noFill/>
-          <a:ln/>
-        </p:spPr>
-        <p:txBody>
-          <a:bodyPr wrap="square" lIns="0" tIns="0" rIns="0" bIns="0" rtlCol="0" anchor="ctr"/>
-          <a:lstStyle/>
-          <a:p>
-            <a:pPr indent="0" marL="0">
-              <a:buNone/>
-            </a:pPr>
-            <a:r>
-              <a:rPr lang="en-US" sz="2800" b="1" dirty="0">
-                <a:solidFill>
-                  <a:srgbClr val="F5EDE0"/>
-                </a:solidFill>
-                <a:latin typeface="Palatino Linotype" pitchFamily="34" charset="0"/>
-                <a:ea typeface="Palatino Linotype" pitchFamily="34" charset="-122"/>
-                <a:cs typeface="Palatino Linotype" pitchFamily="34" charset="-120"/>
-              </a:rPr>
-              <a:t>−11.3% / yr</a:t>
-            </a:r>
-            <a:endParaRPr lang="en-US" sz="2800" dirty="0"/>
-          </a:p>
-        </p:txBody>
-      </p:sp>
-      <p:sp>
-        <p:nvSpPr>
-          <p:cNvPr id="18" name="Text 16"/>
-          <p:cNvSpPr/>
-          <p:nvPr/>
-        </p:nvSpPr>
-        <p:spPr>
-          <a:xfrm>
-            <a:off x="6217920" y="4937760"/>
-            <a:ext cx="3017520" cy="457200"/>
-          </a:xfrm>
-          <a:prstGeom prst="rect">
-            <a:avLst/>
-          </a:prstGeom>
-          <a:noFill/>
-          <a:ln/>
-        </p:spPr>
-        <p:txBody>
-          <a:bodyPr wrap="square" lIns="0" tIns="0" rIns="0" bIns="0" rtlCol="0" anchor="ctr"/>
-          <a:lstStyle/>
-          <a:p>
-            <a:pPr indent="0" marL="0">
-              <a:buNone/>
-            </a:pPr>
-            <a:r>
-              <a:rPr lang="en-US" sz="1600" dirty="0">
-                <a:solidFill>
-                  <a:srgbClr val="8FA898"/>
-                </a:solidFill>
-                <a:latin typeface="Calibri" pitchFamily="34" charset="0"/>
-                <a:ea typeface="Calibri" pitchFamily="34" charset="-122"/>
-                <a:cs typeface="Calibri" pitchFamily="34" charset="-120"/>
-              </a:rPr>
-              <a:t>Cost per month held</a:t>
-            </a:r>
-            <a:endParaRPr lang="en-US" sz="1600" dirty="0"/>
-          </a:p>
-        </p:txBody>
-      </p:sp>
-      <p:sp>
-        <p:nvSpPr>
-          <p:cNvPr id="19" name="Text 17"/>
-          <p:cNvSpPr/>
-          <p:nvPr/>
-        </p:nvSpPr>
-        <p:spPr>
-          <a:xfrm>
-            <a:off x="9235440" y="4846320"/>
-            <a:ext cx="2651760" cy="548640"/>
-          </a:xfrm>
-          <a:prstGeom prst="rect">
-            <a:avLst/>
-          </a:prstGeom>
-          <a:noFill/>
-          <a:ln/>
-        </p:spPr>
-        <p:txBody>
-          <a:bodyPr wrap="square" lIns="0" tIns="0" rIns="0" bIns="0" rtlCol="0" anchor="ctr"/>
-          <a:lstStyle/>
-          <a:p>
-            <a:pPr indent="0" marL="0">
-              <a:buNone/>
-            </a:pPr>
-            <a:r>
-              <a:rPr lang="en-US" sz="2800" b="1" dirty="0">
-                <a:solidFill>
-                  <a:srgbClr val="F5EDE0"/>
-                </a:solidFill>
-                <a:latin typeface="Palatino Linotype" pitchFamily="34" charset="0"/>
-                <a:ea typeface="Palatino Linotype" pitchFamily="34" charset="-122"/>
-                <a:cs typeface="Palatino Linotype" pitchFamily="34" charset="-120"/>
-              </a:rPr>
-              <a:t>−Đ27,755</a:t>
-            </a:r>
-            <a:endParaRPr lang="en-US" sz="2800" dirty="0"/>
-          </a:p>
-        </p:txBody>
-      </p:sp>
-      <p:sp>
-        <p:nvSpPr>
-          <p:cNvPr id="20" name="Text 18"/>
-          <p:cNvSpPr/>
-          <p:nvPr/>
-        </p:nvSpPr>
-        <p:spPr>
-          <a:xfrm>
-            <a:off x="0" y="6035040"/>
-            <a:ext cx="12188952" cy="411480"/>
-          </a:xfrm>
-          <a:prstGeom prst="rect">
-            <a:avLst/>
-          </a:prstGeom>
-          <a:noFill/>
-          <a:ln/>
-        </p:spPr>
-        <p:txBody>
-          <a:bodyPr wrap="square" lIns="0" tIns="0" rIns="0" bIns="0" rtlCol="0" anchor="ctr"/>
-          <a:lstStyle/>
-          <a:p>
-            <a:pPr algn="ctr" indent="0" marL="0">
-              <a:buNone/>
-            </a:pPr>
-            <a:r>
-              <a:rPr lang="en-US" sz="1800" dirty="0">
-                <a:solidFill>
-                  <a:srgbClr val="C9A84C"/>
-                </a:solidFill>
-                <a:latin typeface="Palatino Linotype" pitchFamily="34" charset="0"/>
-                <a:ea typeface="Palatino Linotype" pitchFamily="34" charset="-122"/>
-                <a:cs typeface="Palatino Linotype" pitchFamily="34" charset="-120"/>
-              </a:rPr>
-              <a:t>Bought at the developer’s 2024 release price - the market repriced beneath it</a:t>
-            </a:r>
-            <a:endParaRPr lang="en-US" sz="1800" dirty="0"/>
           </a:p>
         </p:txBody>
       </p:sp>
@@ -3069,7 +2632,7 @@
                 <a:ea typeface="Calibri" pitchFamily="34" charset="-122"/>
                 <a:cs typeface="Calibri" pitchFamily="34" charset="-120"/>
               </a:rPr>
-              <a:t>SAME COMMUNITY · OPPOSITE OUTCOMES</a:t>
+              <a:t>THE MATHS</a:t>
             </a:r>
             <a:endParaRPr lang="en-US" sz="1300" dirty="0"/>
           </a:p>
@@ -3122,24 +2685,63 @@
         </p:nvSpPr>
         <p:spPr>
           <a:xfrm>
-            <a:off x="822960" y="1371600"/>
-            <a:ext cx="5029200" cy="502920"/>
-          </a:xfrm>
-          <a:prstGeom prst="rect">
-            <a:avLst/>
-          </a:prstGeom>
-          <a:noFill/>
-          <a:ln/>
-        </p:spPr>
-        <p:txBody>
-          <a:bodyPr wrap="square" lIns="0" tIns="0" rIns="0" bIns="0" rtlCol="0" anchor="ctr"/>
-          <a:lstStyle/>
-          <a:p>
-            <a:pPr indent="0" marL="0">
-              <a:buNone/>
-            </a:pPr>
-            <a:r>
-              <a:rPr lang="en-US" sz="3000" b="1" dirty="0">
+            <a:off x="822960" y="1463040"/>
+            <a:ext cx="4754880" cy="365760"/>
+          </a:xfrm>
+          <a:prstGeom prst="rect">
+            <a:avLst/>
+          </a:prstGeom>
+          <a:noFill/>
+          <a:ln/>
+        </p:spPr>
+        <p:txBody>
+          <a:bodyPr wrap="square" lIns="0" tIns="0" rIns="0" bIns="0" rtlCol="0" anchor="ctr"/>
+          <a:lstStyle/>
+          <a:p>
+            <a:pPr indent="0" marL="0">
+              <a:buNone/>
+            </a:pPr>
+            <a:r>
+              <a:rPr lang="en-US" sz="1500" dirty="0">
+                <a:solidFill>
+                  <a:srgbClr val="8FA898"/>
+                </a:solidFill>
+                <a:latin typeface="Calibri" pitchFamily="34" charset="0"/>
+                <a:ea typeface="Calibri" pitchFamily="34" charset="-122"/>
+                <a:cs typeface="Calibri" pitchFamily="34" charset="-120"/>
+              </a:rPr>
+              <a:t>Bought from the developer</a:t>
+            </a:r>
+            <a:endParaRPr lang="en-US" sz="1500" dirty="0"/>
+          </a:p>
+        </p:txBody>
+      </p:sp>
+      <p:sp>
+        <p:nvSpPr>
+          <p:cNvPr id="5" name="Text 3"/>
+          <p:cNvSpPr/>
+          <p:nvPr/>
+        </p:nvSpPr>
+        <p:spPr>
+          <a:xfrm>
+            <a:off x="822960" y="1810512"/>
+            <a:ext cx="4937760" cy="502920"/>
+          </a:xfrm>
+          <a:prstGeom prst="rect">
+            <a:avLst/>
+          </a:prstGeom>
+          <a:noFill/>
+          <a:ln/>
+        </p:spPr>
+        <p:txBody>
+          <a:bodyPr wrap="square" lIns="0" tIns="0" rIns="0" bIns="0" rtlCol="0" anchor="ctr"/>
+          <a:lstStyle/>
+          <a:p>
+            <a:pPr indent="0" marL="0">
+              <a:buNone/>
+            </a:pPr>
+            <a:r>
+              <a:rPr lang="en-US" sz="2500" b="1" dirty="0">
                 <a:solidFill>
                   <a:srgbClr val="F5EDE0"/>
                 </a:solidFill>
@@ -3147,38 +2749,38 @@
                 <a:ea typeface="Palatino Linotype" pitchFamily="34" charset="-122"/>
                 <a:cs typeface="Palatino Linotype" pitchFamily="34" charset="-120"/>
               </a:rPr>
-              <a:t>Costa Brava</a:t>
-            </a:r>
-            <a:endParaRPr lang="en-US" sz="3000" dirty="0"/>
-          </a:p>
-        </p:txBody>
-      </p:sp>
-      <p:sp>
-        <p:nvSpPr>
-          <p:cNvPr id="5" name="Text 3"/>
-          <p:cNvSpPr/>
-          <p:nvPr/>
-        </p:nvSpPr>
-        <p:spPr>
-          <a:xfrm>
-            <a:off x="822960" y="1920240"/>
-            <a:ext cx="5029200" cy="365760"/>
-          </a:xfrm>
-          <a:prstGeom prst="rect">
-            <a:avLst/>
-          </a:prstGeom>
-          <a:noFill/>
-          <a:ln/>
-        </p:spPr>
-        <p:txBody>
-          <a:bodyPr wrap="square" lIns="0" tIns="0" rIns="0" bIns="0" rtlCol="0" anchor="ctr"/>
-          <a:lstStyle/>
-          <a:p>
-            <a:pPr indent="0" marL="0">
-              <a:buNone/>
-            </a:pPr>
-            <a:r>
-              <a:rPr lang="en-US" sz="1400" b="1" spc="200" kern="0" dirty="0">
+              <a:t>Đ3,082,860  ·  Sep 2024</a:t>
+            </a:r>
+            <a:endParaRPr lang="en-US" sz="2500" dirty="0"/>
+          </a:p>
+        </p:txBody>
+      </p:sp>
+      <p:sp>
+        <p:nvSpPr>
+          <p:cNvPr id="6" name="Text 4"/>
+          <p:cNvSpPr/>
+          <p:nvPr/>
+        </p:nvSpPr>
+        <p:spPr>
+          <a:xfrm>
+            <a:off x="822960" y="2514600"/>
+            <a:ext cx="4754880" cy="365760"/>
+          </a:xfrm>
+          <a:prstGeom prst="rect">
+            <a:avLst/>
+          </a:prstGeom>
+          <a:noFill/>
+          <a:ln/>
+        </p:spPr>
+        <p:txBody>
+          <a:bodyPr wrap="square" lIns="0" tIns="0" rIns="0" bIns="0" rtlCol="0" anchor="ctr"/>
+          <a:lstStyle/>
+          <a:p>
+            <a:pPr indent="0" marL="0">
+              <a:buNone/>
+            </a:pPr>
+            <a:r>
+              <a:rPr lang="en-US" sz="1500" dirty="0">
                 <a:solidFill>
                   <a:srgbClr val="8FA898"/>
                 </a:solidFill>
@@ -3186,38 +2788,77 @@
                 <a:ea typeface="Calibri" pitchFamily="34" charset="-122"/>
                 <a:cs typeface="Calibri" pitchFamily="34" charset="-120"/>
               </a:rPr>
-              <a:t>BOUGHT AT LAUNCH · JAN 2022</a:t>
-            </a:r>
-            <a:endParaRPr lang="en-US" sz="1400" dirty="0"/>
-          </a:p>
-        </p:txBody>
-      </p:sp>
-      <p:sp>
-        <p:nvSpPr>
-          <p:cNvPr id="6" name="Text 4"/>
-          <p:cNvSpPr/>
-          <p:nvPr/>
-        </p:nvSpPr>
-        <p:spPr>
-          <a:xfrm>
-            <a:off x="822960" y="2560320"/>
-            <a:ext cx="2377440" cy="365760"/>
-          </a:xfrm>
-          <a:prstGeom prst="rect">
-            <a:avLst/>
-          </a:prstGeom>
-          <a:noFill/>
-          <a:ln/>
-        </p:spPr>
-        <p:txBody>
-          <a:bodyPr wrap="square" lIns="0" tIns="0" rIns="0" bIns="0" rtlCol="0" anchor="ctr"/>
-          <a:lstStyle/>
-          <a:p>
-            <a:pPr indent="0" marL="0">
-              <a:buNone/>
-            </a:pPr>
-            <a:r>
-              <a:rPr lang="en-US" sz="1400" dirty="0">
+              <a:t>Sold</a:t>
+            </a:r>
+            <a:endParaRPr lang="en-US" sz="1500" dirty="0"/>
+          </a:p>
+        </p:txBody>
+      </p:sp>
+      <p:sp>
+        <p:nvSpPr>
+          <p:cNvPr id="7" name="Text 5"/>
+          <p:cNvSpPr/>
+          <p:nvPr/>
+        </p:nvSpPr>
+        <p:spPr>
+          <a:xfrm>
+            <a:off x="822960" y="2862072"/>
+            <a:ext cx="4937760" cy="502920"/>
+          </a:xfrm>
+          <a:prstGeom prst="rect">
+            <a:avLst/>
+          </a:prstGeom>
+          <a:noFill/>
+          <a:ln/>
+        </p:spPr>
+        <p:txBody>
+          <a:bodyPr wrap="square" lIns="0" tIns="0" rIns="0" bIns="0" rtlCol="0" anchor="ctr"/>
+          <a:lstStyle/>
+          <a:p>
+            <a:pPr indent="0" marL="0">
+              <a:buNone/>
+            </a:pPr>
+            <a:r>
+              <a:rPr lang="en-US" sz="2500" b="1" dirty="0">
+                <a:solidFill>
+                  <a:srgbClr val="F5EDE0"/>
+                </a:solidFill>
+                <a:latin typeface="Palatino Linotype" pitchFamily="34" charset="0"/>
+                <a:ea typeface="Palatino Linotype" pitchFamily="34" charset="-122"/>
+                <a:cs typeface="Palatino Linotype" pitchFamily="34" charset="-120"/>
+              </a:rPr>
+              <a:t>Đ2,500,000  ·  Jun 2026</a:t>
+            </a:r>
+            <a:endParaRPr lang="en-US" sz="2500" dirty="0"/>
+          </a:p>
+        </p:txBody>
+      </p:sp>
+      <p:sp>
+        <p:nvSpPr>
+          <p:cNvPr id="8" name="Text 6"/>
+          <p:cNvSpPr/>
+          <p:nvPr/>
+        </p:nvSpPr>
+        <p:spPr>
+          <a:xfrm>
+            <a:off x="822960" y="3566160"/>
+            <a:ext cx="4754880" cy="365760"/>
+          </a:xfrm>
+          <a:prstGeom prst="rect">
+            <a:avLst/>
+          </a:prstGeom>
+          <a:noFill/>
+          <a:ln/>
+        </p:spPr>
+        <p:txBody>
+          <a:bodyPr wrap="square" lIns="0" tIns="0" rIns="0" bIns="0" rtlCol="0" anchor="ctr"/>
+          <a:lstStyle/>
+          <a:p>
+            <a:pPr indent="0" marL="0">
+              <a:buNone/>
+            </a:pPr>
+            <a:r>
+              <a:rPr lang="en-US" sz="1500" dirty="0">
                 <a:solidFill>
                   <a:srgbClr val="8FA898"/>
                 </a:solidFill>
@@ -3225,38 +2866,38 @@
                 <a:ea typeface="Calibri" pitchFamily="34" charset="-122"/>
                 <a:cs typeface="Calibri" pitchFamily="34" charset="-120"/>
               </a:rPr>
-              <a:t>Bought</a:t>
-            </a:r>
-            <a:endParaRPr lang="en-US" sz="1400" dirty="0"/>
-          </a:p>
-        </p:txBody>
-      </p:sp>
-      <p:sp>
-        <p:nvSpPr>
-          <p:cNvPr id="7" name="Text 5"/>
-          <p:cNvSpPr/>
-          <p:nvPr/>
-        </p:nvSpPr>
-        <p:spPr>
-          <a:xfrm>
-            <a:off x="3017520" y="2514600"/>
-            <a:ext cx="2834640" cy="457200"/>
-          </a:xfrm>
-          <a:prstGeom prst="rect">
-            <a:avLst/>
-          </a:prstGeom>
-          <a:noFill/>
-          <a:ln/>
-        </p:spPr>
-        <p:txBody>
-          <a:bodyPr wrap="square" lIns="0" tIns="0" rIns="0" bIns="0" rtlCol="0" anchor="ctr"/>
-          <a:lstStyle/>
-          <a:p>
-            <a:pPr indent="0" marL="0">
-              <a:buNone/>
-            </a:pPr>
-            <a:r>
-              <a:rPr lang="en-US" sz="2000" b="1" dirty="0">
+              <a:t>Time held</a:t>
+            </a:r>
+            <a:endParaRPr lang="en-US" sz="1500" dirty="0"/>
+          </a:p>
+        </p:txBody>
+      </p:sp>
+      <p:sp>
+        <p:nvSpPr>
+          <p:cNvPr id="9" name="Text 7"/>
+          <p:cNvSpPr/>
+          <p:nvPr/>
+        </p:nvSpPr>
+        <p:spPr>
+          <a:xfrm>
+            <a:off x="822960" y="3913632"/>
+            <a:ext cx="4937760" cy="502920"/>
+          </a:xfrm>
+          <a:prstGeom prst="rect">
+            <a:avLst/>
+          </a:prstGeom>
+          <a:noFill/>
+          <a:ln/>
+        </p:spPr>
+        <p:txBody>
+          <a:bodyPr wrap="square" lIns="0" tIns="0" rIns="0" bIns="0" rtlCol="0" anchor="ctr"/>
+          <a:lstStyle/>
+          <a:p>
+            <a:pPr indent="0" marL="0">
+              <a:buNone/>
+            </a:pPr>
+            <a:r>
+              <a:rPr lang="en-US" sz="2500" b="1" dirty="0">
                 <a:solidFill>
                   <a:srgbClr val="F5EDE0"/>
                 </a:solidFill>
@@ -3264,38 +2905,38 @@
                 <a:ea typeface="Palatino Linotype" pitchFamily="34" charset="-122"/>
                 <a:cs typeface="Palatino Linotype" pitchFamily="34" charset="-120"/>
               </a:rPr>
-              <a:t>Đ1,789,000</a:t>
-            </a:r>
-            <a:endParaRPr lang="en-US" sz="2000" dirty="0"/>
-          </a:p>
-        </p:txBody>
-      </p:sp>
-      <p:sp>
-        <p:nvSpPr>
-          <p:cNvPr id="8" name="Text 6"/>
-          <p:cNvSpPr/>
-          <p:nvPr/>
-        </p:nvSpPr>
-        <p:spPr>
-          <a:xfrm>
-            <a:off x="822960" y="3127248"/>
-            <a:ext cx="2377440" cy="365760"/>
-          </a:xfrm>
-          <a:prstGeom prst="rect">
-            <a:avLst/>
-          </a:prstGeom>
-          <a:noFill/>
-          <a:ln/>
-        </p:spPr>
-        <p:txBody>
-          <a:bodyPr wrap="square" lIns="0" tIns="0" rIns="0" bIns="0" rtlCol="0" anchor="ctr"/>
-          <a:lstStyle/>
-          <a:p>
-            <a:pPr indent="0" marL="0">
-              <a:buNone/>
-            </a:pPr>
-            <a:r>
-              <a:rPr lang="en-US" sz="1400" dirty="0">
+              <a:t>21 months</a:t>
+            </a:r>
+            <a:endParaRPr lang="en-US" sz="2500" dirty="0"/>
+          </a:p>
+        </p:txBody>
+      </p:sp>
+      <p:sp>
+        <p:nvSpPr>
+          <p:cNvPr id="10" name="Text 8"/>
+          <p:cNvSpPr/>
+          <p:nvPr/>
+        </p:nvSpPr>
+        <p:spPr>
+          <a:xfrm>
+            <a:off x="822960" y="4617720"/>
+            <a:ext cx="4754880" cy="365760"/>
+          </a:xfrm>
+          <a:prstGeom prst="rect">
+            <a:avLst/>
+          </a:prstGeom>
+          <a:noFill/>
+          <a:ln/>
+        </p:spPr>
+        <p:txBody>
+          <a:bodyPr wrap="square" lIns="0" tIns="0" rIns="0" bIns="0" rtlCol="0" anchor="ctr"/>
+          <a:lstStyle/>
+          <a:p>
+            <a:pPr indent="0" marL="0">
+              <a:buNone/>
+            </a:pPr>
+            <a:r>
+              <a:rPr lang="en-US" sz="1500" dirty="0">
                 <a:solidFill>
                   <a:srgbClr val="8FA898"/>
                 </a:solidFill>
@@ -3303,38 +2944,38 @@
                 <a:ea typeface="Calibri" pitchFamily="34" charset="-122"/>
                 <a:cs typeface="Calibri" pitchFamily="34" charset="-120"/>
               </a:rPr>
-              <a:t>Worth now</a:t>
-            </a:r>
-            <a:endParaRPr lang="en-US" sz="1400" dirty="0"/>
-          </a:p>
-        </p:txBody>
-      </p:sp>
-      <p:sp>
-        <p:nvSpPr>
-          <p:cNvPr id="9" name="Text 7"/>
-          <p:cNvSpPr/>
-          <p:nvPr/>
-        </p:nvSpPr>
-        <p:spPr>
-          <a:xfrm>
-            <a:off x="3017520" y="3081528"/>
-            <a:ext cx="2834640" cy="457200"/>
-          </a:xfrm>
-          <a:prstGeom prst="rect">
-            <a:avLst/>
-          </a:prstGeom>
-          <a:noFill/>
-          <a:ln/>
-        </p:spPr>
-        <p:txBody>
-          <a:bodyPr wrap="square" lIns="0" tIns="0" rIns="0" bIns="0" rtlCol="0" anchor="ctr"/>
-          <a:lstStyle/>
-          <a:p>
-            <a:pPr indent="0" marL="0">
-              <a:buNone/>
-            </a:pPr>
-            <a:r>
-              <a:rPr lang="en-US" sz="2000" b="1" dirty="0">
+              <a:t>Price per sqft</a:t>
+            </a:r>
+            <a:endParaRPr lang="en-US" sz="1500" dirty="0"/>
+          </a:p>
+        </p:txBody>
+      </p:sp>
+      <p:sp>
+        <p:nvSpPr>
+          <p:cNvPr id="11" name="Text 9"/>
+          <p:cNvSpPr/>
+          <p:nvPr/>
+        </p:nvSpPr>
+        <p:spPr>
+          <a:xfrm>
+            <a:off x="822960" y="4965192"/>
+            <a:ext cx="4937760" cy="502920"/>
+          </a:xfrm>
+          <a:prstGeom prst="rect">
+            <a:avLst/>
+          </a:prstGeom>
+          <a:noFill/>
+          <a:ln/>
+        </p:spPr>
+        <p:txBody>
+          <a:bodyPr wrap="square" lIns="0" tIns="0" rIns="0" bIns="0" rtlCol="0" anchor="ctr"/>
+          <a:lstStyle/>
+          <a:p>
+            <a:pPr indent="0" marL="0">
+              <a:buNone/>
+            </a:pPr>
+            <a:r>
+              <a:rPr lang="en-US" sz="2500" b="1" dirty="0">
                 <a:solidFill>
                   <a:srgbClr val="F5EDE0"/>
                 </a:solidFill>
@@ -3342,46 +2983,46 @@
                 <a:ea typeface="Palatino Linotype" pitchFamily="34" charset="-122"/>
                 <a:cs typeface="Palatino Linotype" pitchFamily="34" charset="-120"/>
               </a:rPr>
-              <a:t>Đ2,680,000</a:t>
-            </a:r>
-            <a:endParaRPr lang="en-US" sz="2000" dirty="0"/>
-          </a:p>
-        </p:txBody>
-      </p:sp>
-      <p:sp>
-        <p:nvSpPr>
-          <p:cNvPr id="10" name="Text 8"/>
-          <p:cNvSpPr/>
-          <p:nvPr/>
-        </p:nvSpPr>
-        <p:spPr>
-          <a:xfrm>
-            <a:off x="822960" y="3694176"/>
-            <a:ext cx="2377440" cy="365760"/>
-          </a:xfrm>
-          <a:prstGeom prst="rect">
-            <a:avLst/>
-          </a:prstGeom>
-          <a:noFill/>
-          <a:ln/>
-        </p:spPr>
-        <p:txBody>
-          <a:bodyPr wrap="square" lIns="0" tIns="0" rIns="0" bIns="0" rtlCol="0" anchor="ctr"/>
-          <a:lstStyle/>
-          <a:p>
-            <a:pPr indent="0" marL="0">
-              <a:buNone/>
-            </a:pPr>
-            <a:r>
-              <a:rPr lang="en-US" sz="1400" dirty="0">
-                <a:solidFill>
-                  <a:srgbClr val="8FA898"/>
+              <a:t>Đ1,382  →  Đ1,121</a:t>
+            </a:r>
+            <a:endParaRPr lang="en-US" sz="2500" dirty="0"/>
+          </a:p>
+        </p:txBody>
+      </p:sp>
+      <p:sp>
+        <p:nvSpPr>
+          <p:cNvPr id="12" name="Text 10"/>
+          <p:cNvSpPr/>
+          <p:nvPr/>
+        </p:nvSpPr>
+        <p:spPr>
+          <a:xfrm>
+            <a:off x="6217920" y="1417320"/>
+            <a:ext cx="5303520" cy="320040"/>
+          </a:xfrm>
+          <a:prstGeom prst="rect">
+            <a:avLst/>
+          </a:prstGeom>
+          <a:noFill/>
+          <a:ln/>
+        </p:spPr>
+        <p:txBody>
+          <a:bodyPr wrap="square" lIns="0" tIns="0" rIns="0" bIns="0" rtlCol="0" anchor="ctr"/>
+          <a:lstStyle/>
+          <a:p>
+            <a:pPr indent="0" marL="0">
+              <a:buNone/>
+            </a:pPr>
+            <a:r>
+              <a:rPr lang="en-US" sz="1400" b="1" spc="300" kern="0" dirty="0">
+                <a:solidFill>
+                  <a:srgbClr val="C9A84C"/>
                 </a:solidFill>
                 <a:latin typeface="Calibri" pitchFamily="34" charset="0"/>
                 <a:ea typeface="Calibri" pitchFamily="34" charset="-122"/>
                 <a:cs typeface="Calibri" pitchFamily="34" charset="-120"/>
               </a:rPr>
-              <a:t>Held</a:t>
+              <a:t>LOSS</a:t>
             </a:r>
             <a:endParaRPr lang="en-US" sz="1400" dirty="0"/>
           </a:p>
@@ -3389,108 +3030,186 @@
       </p:sp>
       <p:sp>
         <p:nvSpPr>
-          <p:cNvPr id="11" name="Text 9"/>
-          <p:cNvSpPr/>
-          <p:nvPr/>
-        </p:nvSpPr>
-        <p:spPr>
-          <a:xfrm>
-            <a:off x="3017520" y="3648456"/>
-            <a:ext cx="2834640" cy="457200"/>
-          </a:xfrm>
-          <a:prstGeom prst="rect">
-            <a:avLst/>
-          </a:prstGeom>
-          <a:noFill/>
-          <a:ln/>
-        </p:spPr>
-        <p:txBody>
-          <a:bodyPr wrap="square" lIns="0" tIns="0" rIns="0" bIns="0" rtlCol="0" anchor="ctr"/>
-          <a:lstStyle/>
-          <a:p>
-            <a:pPr indent="0" marL="0">
-              <a:buNone/>
-            </a:pPr>
-            <a:r>
-              <a:rPr lang="en-US" sz="2000" b="1" dirty="0">
-                <a:solidFill>
-                  <a:srgbClr val="F5EDE0"/>
+          <p:cNvPr id="13" name="Text 11"/>
+          <p:cNvSpPr/>
+          <p:nvPr/>
+        </p:nvSpPr>
+        <p:spPr>
+          <a:xfrm>
+            <a:off x="6217920" y="1737360"/>
+            <a:ext cx="5669280" cy="914400"/>
+          </a:xfrm>
+          <a:prstGeom prst="rect">
+            <a:avLst/>
+          </a:prstGeom>
+          <a:noFill/>
+          <a:ln/>
+        </p:spPr>
+        <p:txBody>
+          <a:bodyPr wrap="square" lIns="0" tIns="0" rIns="0" bIns="0" rtlCol="0" anchor="ctr"/>
+          <a:lstStyle/>
+          <a:p>
+            <a:pPr indent="0" marL="0">
+              <a:buNone/>
+            </a:pPr>
+            <a:r>
+              <a:rPr lang="en-US" sz="5000" b="1" dirty="0">
+                <a:solidFill>
+                  <a:srgbClr val="E8C96B"/>
                 </a:solidFill>
                 <a:latin typeface="Palatino Linotype" pitchFamily="34" charset="0"/>
                 <a:ea typeface="Palatino Linotype" pitchFamily="34" charset="-122"/>
                 <a:cs typeface="Palatino Linotype" pitchFamily="34" charset="-120"/>
               </a:rPr>
-              <a:t>4.5 years</a:t>
-            </a:r>
-            <a:endParaRPr lang="en-US" sz="2000" dirty="0"/>
-          </a:p>
-        </p:txBody>
-      </p:sp>
-      <p:sp>
-        <p:nvSpPr>
-          <p:cNvPr id="12" name="Text 10"/>
-          <p:cNvSpPr/>
-          <p:nvPr/>
-        </p:nvSpPr>
-        <p:spPr>
-          <a:xfrm>
-            <a:off x="822960" y="4663440"/>
-            <a:ext cx="5029200" cy="822960"/>
-          </a:xfrm>
-          <a:prstGeom prst="rect">
-            <a:avLst/>
-          </a:prstGeom>
-          <a:noFill/>
-          <a:ln/>
-        </p:spPr>
-        <p:txBody>
-          <a:bodyPr wrap="square" lIns="0" tIns="0" rIns="0" bIns="0" rtlCol="0" anchor="ctr"/>
-          <a:lstStyle/>
-          <a:p>
-            <a:pPr indent="0" marL="0">
-              <a:buNone/>
-            </a:pPr>
-            <a:r>
-              <a:rPr lang="en-US" sz="4400" b="1" dirty="0">
-                <a:solidFill>
-                  <a:srgbClr val="E8C96B"/>
+              <a:t>−Đ582,860</a:t>
+            </a:r>
+            <a:endParaRPr lang="en-US" sz="5000" dirty="0"/>
+          </a:p>
+        </p:txBody>
+      </p:sp>
+      <p:sp>
+        <p:nvSpPr>
+          <p:cNvPr id="14" name="Text 12"/>
+          <p:cNvSpPr/>
+          <p:nvPr/>
+        </p:nvSpPr>
+        <p:spPr>
+          <a:xfrm>
+            <a:off x="6217920" y="3200400"/>
+            <a:ext cx="3017520" cy="457200"/>
+          </a:xfrm>
+          <a:prstGeom prst="rect">
+            <a:avLst/>
+          </a:prstGeom>
+          <a:noFill/>
+          <a:ln/>
+        </p:spPr>
+        <p:txBody>
+          <a:bodyPr wrap="square" lIns="0" tIns="0" rIns="0" bIns="0" rtlCol="0" anchor="ctr"/>
+          <a:lstStyle/>
+          <a:p>
+            <a:pPr indent="0" marL="0">
+              <a:buNone/>
+            </a:pPr>
+            <a:r>
+              <a:rPr lang="en-US" sz="1600" dirty="0">
+                <a:solidFill>
+                  <a:srgbClr val="8FA898"/>
+                </a:solidFill>
+                <a:latin typeface="Calibri" pitchFamily="34" charset="0"/>
+                <a:ea typeface="Calibri" pitchFamily="34" charset="-122"/>
+                <a:cs typeface="Calibri" pitchFamily="34" charset="-120"/>
+              </a:rPr>
+              <a:t>ROI on full price</a:t>
+            </a:r>
+            <a:endParaRPr lang="en-US" sz="1600" dirty="0"/>
+          </a:p>
+        </p:txBody>
+      </p:sp>
+      <p:sp>
+        <p:nvSpPr>
+          <p:cNvPr id="15" name="Text 13"/>
+          <p:cNvSpPr/>
+          <p:nvPr/>
+        </p:nvSpPr>
+        <p:spPr>
+          <a:xfrm>
+            <a:off x="9235440" y="3108960"/>
+            <a:ext cx="2651760" cy="548640"/>
+          </a:xfrm>
+          <a:prstGeom prst="rect">
+            <a:avLst/>
+          </a:prstGeom>
+          <a:noFill/>
+          <a:ln/>
+        </p:spPr>
+        <p:txBody>
+          <a:bodyPr wrap="square" lIns="0" tIns="0" rIns="0" bIns="0" rtlCol="0" anchor="ctr"/>
+          <a:lstStyle/>
+          <a:p>
+            <a:pPr indent="0" marL="0">
+              <a:buNone/>
+            </a:pPr>
+            <a:r>
+              <a:rPr lang="en-US" sz="2800" b="1" dirty="0">
+                <a:solidFill>
+                  <a:srgbClr val="F5EDE0"/>
                 </a:solidFill>
                 <a:latin typeface="Palatino Linotype" pitchFamily="34" charset="0"/>
                 <a:ea typeface="Palatino Linotype" pitchFamily="34" charset="-122"/>
                 <a:cs typeface="Palatino Linotype" pitchFamily="34" charset="-120"/>
               </a:rPr>
-              <a:t>+Đ819,440</a:t>
-            </a:r>
-            <a:endParaRPr lang="en-US" sz="4400" dirty="0"/>
-          </a:p>
-        </p:txBody>
-      </p:sp>
-      <p:sp>
-        <p:nvSpPr>
-          <p:cNvPr id="13" name="Text 11"/>
-          <p:cNvSpPr/>
-          <p:nvPr/>
-        </p:nvSpPr>
-        <p:spPr>
-          <a:xfrm>
-            <a:off x="6400800" y="1371600"/>
-            <a:ext cx="5029200" cy="502920"/>
-          </a:xfrm>
-          <a:prstGeom prst="rect">
-            <a:avLst/>
-          </a:prstGeom>
-          <a:noFill/>
-          <a:ln/>
-        </p:spPr>
-        <p:txBody>
-          <a:bodyPr wrap="square" lIns="0" tIns="0" rIns="0" bIns="0" rtlCol="0" anchor="ctr"/>
-          <a:lstStyle/>
-          <a:p>
-            <a:pPr indent="0" marL="0">
-              <a:buNone/>
-            </a:pPr>
-            <a:r>
-              <a:rPr lang="en-US" sz="3000" b="1" dirty="0">
+              <a:t>−18.9%</a:t>
+            </a:r>
+            <a:endParaRPr lang="en-US" sz="2800" dirty="0"/>
+          </a:p>
+        </p:txBody>
+      </p:sp>
+      <p:sp>
+        <p:nvSpPr>
+          <p:cNvPr id="16" name="Text 14"/>
+          <p:cNvSpPr/>
+          <p:nvPr/>
+        </p:nvSpPr>
+        <p:spPr>
+          <a:xfrm>
+            <a:off x="6217920" y="4069080"/>
+            <a:ext cx="3017520" cy="457200"/>
+          </a:xfrm>
+          <a:prstGeom prst="rect">
+            <a:avLst/>
+          </a:prstGeom>
+          <a:noFill/>
+          <a:ln/>
+        </p:spPr>
+        <p:txBody>
+          <a:bodyPr wrap="square" lIns="0" tIns="0" rIns="0" bIns="0" rtlCol="0" anchor="ctr"/>
+          <a:lstStyle/>
+          <a:p>
+            <a:pPr indent="0" marL="0">
+              <a:buNone/>
+            </a:pPr>
+            <a:r>
+              <a:rPr lang="en-US" sz="1600" dirty="0">
+                <a:solidFill>
+                  <a:srgbClr val="8FA898"/>
+                </a:solidFill>
+                <a:latin typeface="Calibri" pitchFamily="34" charset="0"/>
+                <a:ea typeface="Calibri" pitchFamily="34" charset="-122"/>
+                <a:cs typeface="Calibri" pitchFamily="34" charset="-120"/>
+              </a:rPr>
+              <a:t>ROE on cash in</a:t>
+            </a:r>
+            <a:endParaRPr lang="en-US" sz="1600" dirty="0"/>
+          </a:p>
+        </p:txBody>
+      </p:sp>
+      <p:sp>
+        <p:nvSpPr>
+          <p:cNvPr id="17" name="Text 15"/>
+          <p:cNvSpPr/>
+          <p:nvPr/>
+        </p:nvSpPr>
+        <p:spPr>
+          <a:xfrm>
+            <a:off x="9235440" y="3977640"/>
+            <a:ext cx="2651760" cy="548640"/>
+          </a:xfrm>
+          <a:prstGeom prst="rect">
+            <a:avLst/>
+          </a:prstGeom>
+          <a:noFill/>
+          <a:ln/>
+        </p:spPr>
+        <p:txBody>
+          <a:bodyPr wrap="square" lIns="0" tIns="0" rIns="0" bIns="0" rtlCol="0" anchor="ctr"/>
+          <a:lstStyle/>
+          <a:p>
+            <a:pPr indent="0" marL="0">
+              <a:buNone/>
+            </a:pPr>
+            <a:r>
+              <a:rPr lang="en-US" sz="2800" b="1" dirty="0">
                 <a:solidFill>
                   <a:srgbClr val="F5EDE0"/>
                 </a:solidFill>
@@ -3498,38 +3217,38 @@
                 <a:ea typeface="Palatino Linotype" pitchFamily="34" charset="-122"/>
                 <a:cs typeface="Palatino Linotype" pitchFamily="34" charset="-120"/>
               </a:rPr>
-              <a:t>Morocco</a:t>
-            </a:r>
-            <a:endParaRPr lang="en-US" sz="3000" dirty="0"/>
-          </a:p>
-        </p:txBody>
-      </p:sp>
-      <p:sp>
-        <p:nvSpPr>
-          <p:cNvPr id="14" name="Text 12"/>
-          <p:cNvSpPr/>
-          <p:nvPr/>
-        </p:nvSpPr>
-        <p:spPr>
-          <a:xfrm>
-            <a:off x="6400800" y="1920240"/>
-            <a:ext cx="5029200" cy="365760"/>
-          </a:xfrm>
-          <a:prstGeom prst="rect">
-            <a:avLst/>
-          </a:prstGeom>
-          <a:noFill/>
-          <a:ln/>
-        </p:spPr>
-        <p:txBody>
-          <a:bodyPr wrap="square" lIns="0" tIns="0" rIns="0" bIns="0" rtlCol="0" anchor="ctr"/>
-          <a:lstStyle/>
-          <a:p>
-            <a:pPr indent="0" marL="0">
-              <a:buNone/>
-            </a:pPr>
-            <a:r>
-              <a:rPr lang="en-US" sz="1400" b="1" spc="200" kern="0" dirty="0">
+              <a:t>−18.9%</a:t>
+            </a:r>
+            <a:endParaRPr lang="en-US" sz="2800" dirty="0"/>
+          </a:p>
+        </p:txBody>
+      </p:sp>
+      <p:sp>
+        <p:nvSpPr>
+          <p:cNvPr id="18" name="Text 16"/>
+          <p:cNvSpPr/>
+          <p:nvPr/>
+        </p:nvSpPr>
+        <p:spPr>
+          <a:xfrm>
+            <a:off x="6217920" y="4937760"/>
+            <a:ext cx="3017520" cy="457200"/>
+          </a:xfrm>
+          <a:prstGeom prst="rect">
+            <a:avLst/>
+          </a:prstGeom>
+          <a:noFill/>
+          <a:ln/>
+        </p:spPr>
+        <p:txBody>
+          <a:bodyPr wrap="square" lIns="0" tIns="0" rIns="0" bIns="0" rtlCol="0" anchor="ctr"/>
+          <a:lstStyle/>
+          <a:p>
+            <a:pPr indent="0" marL="0">
+              <a:buNone/>
+            </a:pPr>
+            <a:r>
+              <a:rPr lang="en-US" sz="1600" dirty="0">
                 <a:solidFill>
                   <a:srgbClr val="8FA898"/>
                 </a:solidFill>
@@ -3537,77 +3256,38 @@
                 <a:ea typeface="Calibri" pitchFamily="34" charset="-122"/>
                 <a:cs typeface="Calibri" pitchFamily="34" charset="-120"/>
               </a:rPr>
-              <a:t>BOUGHT AT RELEASE · SEP 2024</a:t>
-            </a:r>
-            <a:endParaRPr lang="en-US" sz="1400" dirty="0"/>
-          </a:p>
-        </p:txBody>
-      </p:sp>
-      <p:sp>
-        <p:nvSpPr>
-          <p:cNvPr id="15" name="Text 13"/>
-          <p:cNvSpPr/>
-          <p:nvPr/>
-        </p:nvSpPr>
-        <p:spPr>
-          <a:xfrm>
-            <a:off x="6400800" y="2560320"/>
-            <a:ext cx="2377440" cy="365760"/>
-          </a:xfrm>
-          <a:prstGeom prst="rect">
-            <a:avLst/>
-          </a:prstGeom>
-          <a:noFill/>
-          <a:ln/>
-        </p:spPr>
-        <p:txBody>
-          <a:bodyPr wrap="square" lIns="0" tIns="0" rIns="0" bIns="0" rtlCol="0" anchor="ctr"/>
-          <a:lstStyle/>
-          <a:p>
-            <a:pPr indent="0" marL="0">
-              <a:buNone/>
-            </a:pPr>
-            <a:r>
-              <a:rPr lang="en-US" sz="1400" dirty="0">
-                <a:solidFill>
-                  <a:srgbClr val="8FA898"/>
-                </a:solidFill>
-                <a:latin typeface="Calibri" pitchFamily="34" charset="0"/>
-                <a:ea typeface="Calibri" pitchFamily="34" charset="-122"/>
-                <a:cs typeface="Calibri" pitchFamily="34" charset="-120"/>
-              </a:rPr>
-              <a:t>Bought</a:t>
-            </a:r>
-            <a:endParaRPr lang="en-US" sz="1400" dirty="0"/>
-          </a:p>
-        </p:txBody>
-      </p:sp>
-      <p:sp>
-        <p:nvSpPr>
-          <p:cNvPr id="16" name="Text 14"/>
-          <p:cNvSpPr/>
-          <p:nvPr/>
-        </p:nvSpPr>
-        <p:spPr>
-          <a:xfrm>
-            <a:off x="8595360" y="2514600"/>
-            <a:ext cx="2834640" cy="457200"/>
-          </a:xfrm>
-          <a:prstGeom prst="rect">
-            <a:avLst/>
-          </a:prstGeom>
-          <a:noFill/>
-          <a:ln/>
-        </p:spPr>
-        <p:txBody>
-          <a:bodyPr wrap="square" lIns="0" tIns="0" rIns="0" bIns="0" rtlCol="0" anchor="ctr"/>
-          <a:lstStyle/>
-          <a:p>
-            <a:pPr indent="0" marL="0">
-              <a:buNone/>
-            </a:pPr>
-            <a:r>
-              <a:rPr lang="en-US" sz="2000" b="1" dirty="0">
+              <a:t>IRR (annualised)</a:t>
+            </a:r>
+            <a:endParaRPr lang="en-US" sz="1600" dirty="0"/>
+          </a:p>
+        </p:txBody>
+      </p:sp>
+      <p:sp>
+        <p:nvSpPr>
+          <p:cNvPr id="19" name="Text 17"/>
+          <p:cNvSpPr/>
+          <p:nvPr/>
+        </p:nvSpPr>
+        <p:spPr>
+          <a:xfrm>
+            <a:off x="9235440" y="4846320"/>
+            <a:ext cx="2651760" cy="548640"/>
+          </a:xfrm>
+          <a:prstGeom prst="rect">
+            <a:avLst/>
+          </a:prstGeom>
+          <a:noFill/>
+          <a:ln/>
+        </p:spPr>
+        <p:txBody>
+          <a:bodyPr wrap="square" lIns="0" tIns="0" rIns="0" bIns="0" rtlCol="0" anchor="ctr"/>
+          <a:lstStyle/>
+          <a:p>
+            <a:pPr indent="0" marL="0">
+              <a:buNone/>
+            </a:pPr>
+            <a:r>
+              <a:rPr lang="en-US" sz="2800" b="1" dirty="0">
                 <a:solidFill>
                   <a:srgbClr val="F5EDE0"/>
                 </a:solidFill>
@@ -3615,266 +3295,48 @@
                 <a:ea typeface="Palatino Linotype" pitchFamily="34" charset="-122"/>
                 <a:cs typeface="Palatino Linotype" pitchFamily="34" charset="-120"/>
               </a:rPr>
-              <a:t>Đ3,082,860</a:t>
-            </a:r>
-            <a:endParaRPr lang="en-US" sz="2000" dirty="0"/>
-          </a:p>
-        </p:txBody>
-      </p:sp>
-      <p:sp>
-        <p:nvSpPr>
-          <p:cNvPr id="17" name="Text 15"/>
-          <p:cNvSpPr/>
-          <p:nvPr/>
-        </p:nvSpPr>
-        <p:spPr>
-          <a:xfrm>
-            <a:off x="6400800" y="3127248"/>
-            <a:ext cx="2377440" cy="365760"/>
-          </a:xfrm>
-          <a:prstGeom prst="rect">
-            <a:avLst/>
-          </a:prstGeom>
-          <a:noFill/>
-          <a:ln/>
-        </p:spPr>
-        <p:txBody>
-          <a:bodyPr wrap="square" lIns="0" tIns="0" rIns="0" bIns="0" rtlCol="0" anchor="ctr"/>
-          <a:lstStyle/>
-          <a:p>
-            <a:pPr indent="0" marL="0">
-              <a:buNone/>
-            </a:pPr>
-            <a:r>
-              <a:rPr lang="en-US" sz="1400" dirty="0">
-                <a:solidFill>
-                  <a:srgbClr val="8FA898"/>
-                </a:solidFill>
-                <a:latin typeface="Calibri" pitchFamily="34" charset="0"/>
-                <a:ea typeface="Calibri" pitchFamily="34" charset="-122"/>
-                <a:cs typeface="Calibri" pitchFamily="34" charset="-120"/>
-              </a:rPr>
-              <a:t>Sold</a:t>
-            </a:r>
-            <a:endParaRPr lang="en-US" sz="1400" dirty="0"/>
-          </a:p>
-        </p:txBody>
-      </p:sp>
-      <p:sp>
-        <p:nvSpPr>
-          <p:cNvPr id="18" name="Text 16"/>
-          <p:cNvSpPr/>
-          <p:nvPr/>
-        </p:nvSpPr>
-        <p:spPr>
-          <a:xfrm>
-            <a:off x="8595360" y="3081528"/>
-            <a:ext cx="2834640" cy="457200"/>
-          </a:xfrm>
-          <a:prstGeom prst="rect">
-            <a:avLst/>
-          </a:prstGeom>
-          <a:noFill/>
-          <a:ln/>
-        </p:spPr>
-        <p:txBody>
-          <a:bodyPr wrap="square" lIns="0" tIns="0" rIns="0" bIns="0" rtlCol="0" anchor="ctr"/>
-          <a:lstStyle/>
-          <a:p>
-            <a:pPr indent="0" marL="0">
-              <a:buNone/>
-            </a:pPr>
-            <a:r>
-              <a:rPr lang="en-US" sz="2000" b="1" dirty="0">
-                <a:solidFill>
-                  <a:srgbClr val="F5EDE0"/>
+              <a:t>−11.3% / yr</a:t>
+            </a:r>
+            <a:endParaRPr lang="en-US" sz="2800" dirty="0"/>
+          </a:p>
+        </p:txBody>
+      </p:sp>
+      <p:sp>
+        <p:nvSpPr>
+          <p:cNvPr id="20" name="Text 18"/>
+          <p:cNvSpPr/>
+          <p:nvPr/>
+        </p:nvSpPr>
+        <p:spPr>
+          <a:xfrm>
+            <a:off x="0" y="6035040"/>
+            <a:ext cx="12188952" cy="411480"/>
+          </a:xfrm>
+          <a:prstGeom prst="rect">
+            <a:avLst/>
+          </a:prstGeom>
+          <a:noFill/>
+          <a:ln/>
+        </p:spPr>
+        <p:txBody>
+          <a:bodyPr wrap="square" lIns="0" tIns="0" rIns="0" bIns="0" rtlCol="0" anchor="ctr"/>
+          <a:lstStyle/>
+          <a:p>
+            <a:pPr algn="ctr" indent="0" marL="0">
+              <a:buNone/>
+            </a:pPr>
+            <a:r>
+              <a:rPr lang="en-US" sz="1800" dirty="0">
+                <a:solidFill>
+                  <a:srgbClr val="C9A84C"/>
                 </a:solidFill>
                 <a:latin typeface="Palatino Linotype" pitchFamily="34" charset="0"/>
                 <a:ea typeface="Palatino Linotype" pitchFamily="34" charset="-122"/>
                 <a:cs typeface="Palatino Linotype" pitchFamily="34" charset="-120"/>
               </a:rPr>
-              <a:t>Đ2,500,000</a:t>
-            </a:r>
-            <a:endParaRPr lang="en-US" sz="2000" dirty="0"/>
-          </a:p>
-        </p:txBody>
-      </p:sp>
-      <p:sp>
-        <p:nvSpPr>
-          <p:cNvPr id="19" name="Text 17"/>
-          <p:cNvSpPr/>
-          <p:nvPr/>
-        </p:nvSpPr>
-        <p:spPr>
-          <a:xfrm>
-            <a:off x="6400800" y="3694176"/>
-            <a:ext cx="2377440" cy="365760"/>
-          </a:xfrm>
-          <a:prstGeom prst="rect">
-            <a:avLst/>
-          </a:prstGeom>
-          <a:noFill/>
-          <a:ln/>
-        </p:spPr>
-        <p:txBody>
-          <a:bodyPr wrap="square" lIns="0" tIns="0" rIns="0" bIns="0" rtlCol="0" anchor="ctr"/>
-          <a:lstStyle/>
-          <a:p>
-            <a:pPr indent="0" marL="0">
-              <a:buNone/>
-            </a:pPr>
-            <a:r>
-              <a:rPr lang="en-US" sz="1400" dirty="0">
-                <a:solidFill>
-                  <a:srgbClr val="8FA898"/>
-                </a:solidFill>
-                <a:latin typeface="Calibri" pitchFamily="34" charset="0"/>
-                <a:ea typeface="Calibri" pitchFamily="34" charset="-122"/>
-                <a:cs typeface="Calibri" pitchFamily="34" charset="-120"/>
-              </a:rPr>
-              <a:t>Held</a:t>
-            </a:r>
-            <a:endParaRPr lang="en-US" sz="1400" dirty="0"/>
-          </a:p>
-        </p:txBody>
-      </p:sp>
-      <p:sp>
-        <p:nvSpPr>
-          <p:cNvPr id="20" name="Text 18"/>
-          <p:cNvSpPr/>
-          <p:nvPr/>
-        </p:nvSpPr>
-        <p:spPr>
-          <a:xfrm>
-            <a:off x="8595360" y="3648456"/>
-            <a:ext cx="2834640" cy="457200"/>
-          </a:xfrm>
-          <a:prstGeom prst="rect">
-            <a:avLst/>
-          </a:prstGeom>
-          <a:noFill/>
-          <a:ln/>
-        </p:spPr>
-        <p:txBody>
-          <a:bodyPr wrap="square" lIns="0" tIns="0" rIns="0" bIns="0" rtlCol="0" anchor="ctr"/>
-          <a:lstStyle/>
-          <a:p>
-            <a:pPr indent="0" marL="0">
-              <a:buNone/>
-            </a:pPr>
-            <a:r>
-              <a:rPr lang="en-US" sz="2000" b="1" dirty="0">
-                <a:solidFill>
-                  <a:srgbClr val="F5EDE0"/>
-                </a:solidFill>
-                <a:latin typeface="Palatino Linotype" pitchFamily="34" charset="0"/>
-                <a:ea typeface="Palatino Linotype" pitchFamily="34" charset="-122"/>
-                <a:cs typeface="Palatino Linotype" pitchFamily="34" charset="-120"/>
-              </a:rPr>
-              <a:t>21 months</a:t>
-            </a:r>
-            <a:endParaRPr lang="en-US" sz="2000" dirty="0"/>
-          </a:p>
-        </p:txBody>
-      </p:sp>
-      <p:sp>
-        <p:nvSpPr>
-          <p:cNvPr id="21" name="Text 19"/>
-          <p:cNvSpPr/>
-          <p:nvPr/>
-        </p:nvSpPr>
-        <p:spPr>
-          <a:xfrm>
-            <a:off x="6400800" y="4663440"/>
-            <a:ext cx="5029200" cy="822960"/>
-          </a:xfrm>
-          <a:prstGeom prst="rect">
-            <a:avLst/>
-          </a:prstGeom>
-          <a:noFill/>
-          <a:ln/>
-        </p:spPr>
-        <p:txBody>
-          <a:bodyPr wrap="square" lIns="0" tIns="0" rIns="0" bIns="0" rtlCol="0" anchor="ctr"/>
-          <a:lstStyle/>
-          <a:p>
-            <a:pPr indent="0" marL="0">
-              <a:buNone/>
-            </a:pPr>
-            <a:r>
-              <a:rPr lang="en-US" sz="4400" b="1" dirty="0">
-                <a:solidFill>
-                  <a:srgbClr val="C9A84C"/>
-                </a:solidFill>
-                <a:latin typeface="Palatino Linotype" pitchFamily="34" charset="0"/>
-                <a:ea typeface="Palatino Linotype" pitchFamily="34" charset="-122"/>
-                <a:cs typeface="Palatino Linotype" pitchFamily="34" charset="-120"/>
-              </a:rPr>
-              <a:t>−Đ582,860</a:t>
-            </a:r>
-            <a:endParaRPr lang="en-US" sz="4400" dirty="0"/>
-          </a:p>
-        </p:txBody>
-      </p:sp>
-      <p:sp>
-        <p:nvSpPr>
-          <p:cNvPr id="22" name="Shape 20"/>
-          <p:cNvSpPr/>
-          <p:nvPr/>
-        </p:nvSpPr>
-        <p:spPr>
-          <a:xfrm>
-            <a:off x="6094476" y="1463040"/>
-            <a:ext cx="0" cy="4206240"/>
-          </a:xfrm>
-          <a:prstGeom prst="line">
-            <a:avLst/>
-          </a:prstGeom>
-          <a:noFill/>
-          <a:ln w="19050">
-            <a:solidFill>
-              <a:srgbClr val="2E5A40"/>
-            </a:solidFill>
-            <a:prstDash val="solid"/>
-          </a:ln>
-        </p:spPr>
-      </p:sp>
-      <p:sp>
-        <p:nvSpPr>
-          <p:cNvPr id="23" name="Text 21"/>
-          <p:cNvSpPr/>
-          <p:nvPr/>
-        </p:nvSpPr>
-        <p:spPr>
-          <a:xfrm>
-            <a:off x="0" y="5943600"/>
-            <a:ext cx="12188952" cy="411480"/>
-          </a:xfrm>
-          <a:prstGeom prst="rect">
-            <a:avLst/>
-          </a:prstGeom>
-          <a:noFill/>
-          <a:ln/>
-        </p:spPr>
-        <p:txBody>
-          <a:bodyPr wrap="square" lIns="0" tIns="0" rIns="0" bIns="0" rtlCol="0" anchor="ctr"/>
-          <a:lstStyle/>
-          <a:p>
-            <a:pPr algn="ctr" indent="0" marL="0">
-              <a:buNone/>
-            </a:pPr>
-            <a:r>
-              <a:rPr lang="en-US" sz="2000" dirty="0">
-                <a:solidFill>
-                  <a:srgbClr val="F5EDE0"/>
-                </a:solidFill>
-                <a:latin typeface="Palatino Linotype" pitchFamily="34" charset="0"/>
-                <a:ea typeface="Palatino Linotype" pitchFamily="34" charset="-122"/>
-                <a:cs typeface="Palatino Linotype" pitchFamily="34" charset="-120"/>
-              </a:rPr>
-              <a:t>Same lagoons. The difference was the entry price.</a:t>
-            </a:r>
-            <a:endParaRPr lang="en-US" sz="2000" dirty="0"/>
+              <a:t>Đ27,755 lost for every month held - bought at the developer’s 2024 release price</a:t>
+            </a:r>
+            <a:endParaRPr lang="en-US" sz="1800" dirty="0"/>
           </a:p>
         </p:txBody>
       </p:sp>
@@ -3943,7 +3405,7 @@
                 <a:ea typeface="Calibri" pitchFamily="34" charset="-122"/>
                 <a:cs typeface="Calibri" pitchFamily="34" charset="-120"/>
               </a:rPr>
-              <a:t>THE VERDICT</a:t>
+              <a:t>SAME COMMUNITY · OPPOSITE OUTCOMES</a:t>
             </a:r>
             <a:endParaRPr lang="en-US" sz="1300" dirty="0"/>
           </a:p>
@@ -3983,6 +3445,880 @@
                 <a:cs typeface="Calibri" pitchFamily="34" charset="-120"/>
               </a:rPr>
               <a:t>06</a:t>
+            </a:r>
+            <a:endParaRPr lang="en-US" sz="1200" dirty="0"/>
+          </a:p>
+        </p:txBody>
+      </p:sp>
+      <p:sp>
+        <p:nvSpPr>
+          <p:cNvPr id="4" name="Text 2"/>
+          <p:cNvSpPr/>
+          <p:nvPr/>
+        </p:nvSpPr>
+        <p:spPr>
+          <a:xfrm>
+            <a:off x="822960" y="1371600"/>
+            <a:ext cx="5029200" cy="502920"/>
+          </a:xfrm>
+          <a:prstGeom prst="rect">
+            <a:avLst/>
+          </a:prstGeom>
+          <a:noFill/>
+          <a:ln/>
+        </p:spPr>
+        <p:txBody>
+          <a:bodyPr wrap="square" lIns="0" tIns="0" rIns="0" bIns="0" rtlCol="0" anchor="ctr"/>
+          <a:lstStyle/>
+          <a:p>
+            <a:pPr indent="0" marL="0">
+              <a:buNone/>
+            </a:pPr>
+            <a:r>
+              <a:rPr lang="en-US" sz="3000" b="1" dirty="0">
+                <a:solidFill>
+                  <a:srgbClr val="F5EDE0"/>
+                </a:solidFill>
+                <a:latin typeface="Palatino Linotype" pitchFamily="34" charset="0"/>
+                <a:ea typeface="Palatino Linotype" pitchFamily="34" charset="-122"/>
+                <a:cs typeface="Palatino Linotype" pitchFamily="34" charset="-120"/>
+              </a:rPr>
+              <a:t>Costa Brava</a:t>
+            </a:r>
+            <a:endParaRPr lang="en-US" sz="3000" dirty="0"/>
+          </a:p>
+        </p:txBody>
+      </p:sp>
+      <p:sp>
+        <p:nvSpPr>
+          <p:cNvPr id="5" name="Text 3"/>
+          <p:cNvSpPr/>
+          <p:nvPr/>
+        </p:nvSpPr>
+        <p:spPr>
+          <a:xfrm>
+            <a:off x="822960" y="1920240"/>
+            <a:ext cx="5029200" cy="365760"/>
+          </a:xfrm>
+          <a:prstGeom prst="rect">
+            <a:avLst/>
+          </a:prstGeom>
+          <a:noFill/>
+          <a:ln/>
+        </p:spPr>
+        <p:txBody>
+          <a:bodyPr wrap="square" lIns="0" tIns="0" rIns="0" bIns="0" rtlCol="0" anchor="ctr"/>
+          <a:lstStyle/>
+          <a:p>
+            <a:pPr indent="0" marL="0">
+              <a:buNone/>
+            </a:pPr>
+            <a:r>
+              <a:rPr lang="en-US" sz="1400" b="1" spc="200" kern="0" dirty="0">
+                <a:solidFill>
+                  <a:srgbClr val="8FA898"/>
+                </a:solidFill>
+                <a:latin typeface="Calibri" pitchFamily="34" charset="0"/>
+                <a:ea typeface="Calibri" pitchFamily="34" charset="-122"/>
+                <a:cs typeface="Calibri" pitchFamily="34" charset="-120"/>
+              </a:rPr>
+              <a:t>BOUGHT AT LAUNCH · JAN 2022</a:t>
+            </a:r>
+            <a:endParaRPr lang="en-US" sz="1400" dirty="0"/>
+          </a:p>
+        </p:txBody>
+      </p:sp>
+      <p:sp>
+        <p:nvSpPr>
+          <p:cNvPr id="6" name="Text 4"/>
+          <p:cNvSpPr/>
+          <p:nvPr/>
+        </p:nvSpPr>
+        <p:spPr>
+          <a:xfrm>
+            <a:off x="822960" y="2560320"/>
+            <a:ext cx="2377440" cy="365760"/>
+          </a:xfrm>
+          <a:prstGeom prst="rect">
+            <a:avLst/>
+          </a:prstGeom>
+          <a:noFill/>
+          <a:ln/>
+        </p:spPr>
+        <p:txBody>
+          <a:bodyPr wrap="square" lIns="0" tIns="0" rIns="0" bIns="0" rtlCol="0" anchor="ctr"/>
+          <a:lstStyle/>
+          <a:p>
+            <a:pPr indent="0" marL="0">
+              <a:buNone/>
+            </a:pPr>
+            <a:r>
+              <a:rPr lang="en-US" sz="1400" dirty="0">
+                <a:solidFill>
+                  <a:srgbClr val="8FA898"/>
+                </a:solidFill>
+                <a:latin typeface="Calibri" pitchFamily="34" charset="0"/>
+                <a:ea typeface="Calibri" pitchFamily="34" charset="-122"/>
+                <a:cs typeface="Calibri" pitchFamily="34" charset="-120"/>
+              </a:rPr>
+              <a:t>Bought</a:t>
+            </a:r>
+            <a:endParaRPr lang="en-US" sz="1400" dirty="0"/>
+          </a:p>
+        </p:txBody>
+      </p:sp>
+      <p:sp>
+        <p:nvSpPr>
+          <p:cNvPr id="7" name="Text 5"/>
+          <p:cNvSpPr/>
+          <p:nvPr/>
+        </p:nvSpPr>
+        <p:spPr>
+          <a:xfrm>
+            <a:off x="3017520" y="2514600"/>
+            <a:ext cx="2834640" cy="457200"/>
+          </a:xfrm>
+          <a:prstGeom prst="rect">
+            <a:avLst/>
+          </a:prstGeom>
+          <a:noFill/>
+          <a:ln/>
+        </p:spPr>
+        <p:txBody>
+          <a:bodyPr wrap="square" lIns="0" tIns="0" rIns="0" bIns="0" rtlCol="0" anchor="ctr"/>
+          <a:lstStyle/>
+          <a:p>
+            <a:pPr indent="0" marL="0">
+              <a:buNone/>
+            </a:pPr>
+            <a:r>
+              <a:rPr lang="en-US" sz="2000" b="1" dirty="0">
+                <a:solidFill>
+                  <a:srgbClr val="F5EDE0"/>
+                </a:solidFill>
+                <a:latin typeface="Palatino Linotype" pitchFamily="34" charset="0"/>
+                <a:ea typeface="Palatino Linotype" pitchFamily="34" charset="-122"/>
+                <a:cs typeface="Palatino Linotype" pitchFamily="34" charset="-120"/>
+              </a:rPr>
+              <a:t>Đ1,789,000</a:t>
+            </a:r>
+            <a:endParaRPr lang="en-US" sz="2000" dirty="0"/>
+          </a:p>
+        </p:txBody>
+      </p:sp>
+      <p:sp>
+        <p:nvSpPr>
+          <p:cNvPr id="8" name="Text 6"/>
+          <p:cNvSpPr/>
+          <p:nvPr/>
+        </p:nvSpPr>
+        <p:spPr>
+          <a:xfrm>
+            <a:off x="822960" y="3127248"/>
+            <a:ext cx="2377440" cy="365760"/>
+          </a:xfrm>
+          <a:prstGeom prst="rect">
+            <a:avLst/>
+          </a:prstGeom>
+          <a:noFill/>
+          <a:ln/>
+        </p:spPr>
+        <p:txBody>
+          <a:bodyPr wrap="square" lIns="0" tIns="0" rIns="0" bIns="0" rtlCol="0" anchor="ctr"/>
+          <a:lstStyle/>
+          <a:p>
+            <a:pPr indent="0" marL="0">
+              <a:buNone/>
+            </a:pPr>
+            <a:r>
+              <a:rPr lang="en-US" sz="1400" dirty="0">
+                <a:solidFill>
+                  <a:srgbClr val="8FA898"/>
+                </a:solidFill>
+                <a:latin typeface="Calibri" pitchFamily="34" charset="0"/>
+                <a:ea typeface="Calibri" pitchFamily="34" charset="-122"/>
+                <a:cs typeface="Calibri" pitchFamily="34" charset="-120"/>
+              </a:rPr>
+              <a:t>Worth now</a:t>
+            </a:r>
+            <a:endParaRPr lang="en-US" sz="1400" dirty="0"/>
+          </a:p>
+        </p:txBody>
+      </p:sp>
+      <p:sp>
+        <p:nvSpPr>
+          <p:cNvPr id="9" name="Text 7"/>
+          <p:cNvSpPr/>
+          <p:nvPr/>
+        </p:nvSpPr>
+        <p:spPr>
+          <a:xfrm>
+            <a:off x="3017520" y="3081528"/>
+            <a:ext cx="2834640" cy="457200"/>
+          </a:xfrm>
+          <a:prstGeom prst="rect">
+            <a:avLst/>
+          </a:prstGeom>
+          <a:noFill/>
+          <a:ln/>
+        </p:spPr>
+        <p:txBody>
+          <a:bodyPr wrap="square" lIns="0" tIns="0" rIns="0" bIns="0" rtlCol="0" anchor="ctr"/>
+          <a:lstStyle/>
+          <a:p>
+            <a:pPr indent="0" marL="0">
+              <a:buNone/>
+            </a:pPr>
+            <a:r>
+              <a:rPr lang="en-US" sz="2000" b="1" dirty="0">
+                <a:solidFill>
+                  <a:srgbClr val="F5EDE0"/>
+                </a:solidFill>
+                <a:latin typeface="Palatino Linotype" pitchFamily="34" charset="0"/>
+                <a:ea typeface="Palatino Linotype" pitchFamily="34" charset="-122"/>
+                <a:cs typeface="Palatino Linotype" pitchFamily="34" charset="-120"/>
+              </a:rPr>
+              <a:t>Đ2,680,000</a:t>
+            </a:r>
+            <a:endParaRPr lang="en-US" sz="2000" dirty="0"/>
+          </a:p>
+        </p:txBody>
+      </p:sp>
+      <p:sp>
+        <p:nvSpPr>
+          <p:cNvPr id="10" name="Text 8"/>
+          <p:cNvSpPr/>
+          <p:nvPr/>
+        </p:nvSpPr>
+        <p:spPr>
+          <a:xfrm>
+            <a:off x="822960" y="3694176"/>
+            <a:ext cx="2377440" cy="365760"/>
+          </a:xfrm>
+          <a:prstGeom prst="rect">
+            <a:avLst/>
+          </a:prstGeom>
+          <a:noFill/>
+          <a:ln/>
+        </p:spPr>
+        <p:txBody>
+          <a:bodyPr wrap="square" lIns="0" tIns="0" rIns="0" bIns="0" rtlCol="0" anchor="ctr"/>
+          <a:lstStyle/>
+          <a:p>
+            <a:pPr indent="0" marL="0">
+              <a:buNone/>
+            </a:pPr>
+            <a:r>
+              <a:rPr lang="en-US" sz="1400" dirty="0">
+                <a:solidFill>
+                  <a:srgbClr val="8FA898"/>
+                </a:solidFill>
+                <a:latin typeface="Calibri" pitchFamily="34" charset="0"/>
+                <a:ea typeface="Calibri" pitchFamily="34" charset="-122"/>
+                <a:cs typeface="Calibri" pitchFamily="34" charset="-120"/>
+              </a:rPr>
+              <a:t>Held</a:t>
+            </a:r>
+            <a:endParaRPr lang="en-US" sz="1400" dirty="0"/>
+          </a:p>
+        </p:txBody>
+      </p:sp>
+      <p:sp>
+        <p:nvSpPr>
+          <p:cNvPr id="11" name="Text 9"/>
+          <p:cNvSpPr/>
+          <p:nvPr/>
+        </p:nvSpPr>
+        <p:spPr>
+          <a:xfrm>
+            <a:off x="3017520" y="3648456"/>
+            <a:ext cx="2834640" cy="457200"/>
+          </a:xfrm>
+          <a:prstGeom prst="rect">
+            <a:avLst/>
+          </a:prstGeom>
+          <a:noFill/>
+          <a:ln/>
+        </p:spPr>
+        <p:txBody>
+          <a:bodyPr wrap="square" lIns="0" tIns="0" rIns="0" bIns="0" rtlCol="0" anchor="ctr"/>
+          <a:lstStyle/>
+          <a:p>
+            <a:pPr indent="0" marL="0">
+              <a:buNone/>
+            </a:pPr>
+            <a:r>
+              <a:rPr lang="en-US" sz="2000" b="1" dirty="0">
+                <a:solidFill>
+                  <a:srgbClr val="F5EDE0"/>
+                </a:solidFill>
+                <a:latin typeface="Palatino Linotype" pitchFamily="34" charset="0"/>
+                <a:ea typeface="Palatino Linotype" pitchFamily="34" charset="-122"/>
+                <a:cs typeface="Palatino Linotype" pitchFamily="34" charset="-120"/>
+              </a:rPr>
+              <a:t>4.5 years</a:t>
+            </a:r>
+            <a:endParaRPr lang="en-US" sz="2000" dirty="0"/>
+          </a:p>
+        </p:txBody>
+      </p:sp>
+      <p:sp>
+        <p:nvSpPr>
+          <p:cNvPr id="12" name="Text 10"/>
+          <p:cNvSpPr/>
+          <p:nvPr/>
+        </p:nvSpPr>
+        <p:spPr>
+          <a:xfrm>
+            <a:off x="822960" y="4663440"/>
+            <a:ext cx="5029200" cy="822960"/>
+          </a:xfrm>
+          <a:prstGeom prst="rect">
+            <a:avLst/>
+          </a:prstGeom>
+          <a:noFill/>
+          <a:ln/>
+        </p:spPr>
+        <p:txBody>
+          <a:bodyPr wrap="square" lIns="0" tIns="0" rIns="0" bIns="0" rtlCol="0" anchor="ctr"/>
+          <a:lstStyle/>
+          <a:p>
+            <a:pPr indent="0" marL="0">
+              <a:buNone/>
+            </a:pPr>
+            <a:r>
+              <a:rPr lang="en-US" sz="4400" b="1" dirty="0">
+                <a:solidFill>
+                  <a:srgbClr val="E8C96B"/>
+                </a:solidFill>
+                <a:latin typeface="Palatino Linotype" pitchFamily="34" charset="0"/>
+                <a:ea typeface="Palatino Linotype" pitchFamily="34" charset="-122"/>
+                <a:cs typeface="Palatino Linotype" pitchFamily="34" charset="-120"/>
+              </a:rPr>
+              <a:t>+Đ819,440</a:t>
+            </a:r>
+            <a:endParaRPr lang="en-US" sz="4400" dirty="0"/>
+          </a:p>
+        </p:txBody>
+      </p:sp>
+      <p:sp>
+        <p:nvSpPr>
+          <p:cNvPr id="13" name="Text 11"/>
+          <p:cNvSpPr/>
+          <p:nvPr/>
+        </p:nvSpPr>
+        <p:spPr>
+          <a:xfrm>
+            <a:off x="6400800" y="1371600"/>
+            <a:ext cx="5029200" cy="502920"/>
+          </a:xfrm>
+          <a:prstGeom prst="rect">
+            <a:avLst/>
+          </a:prstGeom>
+          <a:noFill/>
+          <a:ln/>
+        </p:spPr>
+        <p:txBody>
+          <a:bodyPr wrap="square" lIns="0" tIns="0" rIns="0" bIns="0" rtlCol="0" anchor="ctr"/>
+          <a:lstStyle/>
+          <a:p>
+            <a:pPr indent="0" marL="0">
+              <a:buNone/>
+            </a:pPr>
+            <a:r>
+              <a:rPr lang="en-US" sz="3000" b="1" dirty="0">
+                <a:solidFill>
+                  <a:srgbClr val="F5EDE0"/>
+                </a:solidFill>
+                <a:latin typeface="Palatino Linotype" pitchFamily="34" charset="0"/>
+                <a:ea typeface="Palatino Linotype" pitchFamily="34" charset="-122"/>
+                <a:cs typeface="Palatino Linotype" pitchFamily="34" charset="-120"/>
+              </a:rPr>
+              <a:t>Morocco</a:t>
+            </a:r>
+            <a:endParaRPr lang="en-US" sz="3000" dirty="0"/>
+          </a:p>
+        </p:txBody>
+      </p:sp>
+      <p:sp>
+        <p:nvSpPr>
+          <p:cNvPr id="14" name="Text 12"/>
+          <p:cNvSpPr/>
+          <p:nvPr/>
+        </p:nvSpPr>
+        <p:spPr>
+          <a:xfrm>
+            <a:off x="6400800" y="1920240"/>
+            <a:ext cx="5029200" cy="365760"/>
+          </a:xfrm>
+          <a:prstGeom prst="rect">
+            <a:avLst/>
+          </a:prstGeom>
+          <a:noFill/>
+          <a:ln/>
+        </p:spPr>
+        <p:txBody>
+          <a:bodyPr wrap="square" lIns="0" tIns="0" rIns="0" bIns="0" rtlCol="0" anchor="ctr"/>
+          <a:lstStyle/>
+          <a:p>
+            <a:pPr indent="0" marL="0">
+              <a:buNone/>
+            </a:pPr>
+            <a:r>
+              <a:rPr lang="en-US" sz="1400" b="1" spc="200" kern="0" dirty="0">
+                <a:solidFill>
+                  <a:srgbClr val="8FA898"/>
+                </a:solidFill>
+                <a:latin typeface="Calibri" pitchFamily="34" charset="0"/>
+                <a:ea typeface="Calibri" pitchFamily="34" charset="-122"/>
+                <a:cs typeface="Calibri" pitchFamily="34" charset="-120"/>
+              </a:rPr>
+              <a:t>BOUGHT AT RELEASE · SEP 2024</a:t>
+            </a:r>
+            <a:endParaRPr lang="en-US" sz="1400" dirty="0"/>
+          </a:p>
+        </p:txBody>
+      </p:sp>
+      <p:sp>
+        <p:nvSpPr>
+          <p:cNvPr id="15" name="Text 13"/>
+          <p:cNvSpPr/>
+          <p:nvPr/>
+        </p:nvSpPr>
+        <p:spPr>
+          <a:xfrm>
+            <a:off x="6400800" y="2560320"/>
+            <a:ext cx="2377440" cy="365760"/>
+          </a:xfrm>
+          <a:prstGeom prst="rect">
+            <a:avLst/>
+          </a:prstGeom>
+          <a:noFill/>
+          <a:ln/>
+        </p:spPr>
+        <p:txBody>
+          <a:bodyPr wrap="square" lIns="0" tIns="0" rIns="0" bIns="0" rtlCol="0" anchor="ctr"/>
+          <a:lstStyle/>
+          <a:p>
+            <a:pPr indent="0" marL="0">
+              <a:buNone/>
+            </a:pPr>
+            <a:r>
+              <a:rPr lang="en-US" sz="1400" dirty="0">
+                <a:solidFill>
+                  <a:srgbClr val="8FA898"/>
+                </a:solidFill>
+                <a:latin typeface="Calibri" pitchFamily="34" charset="0"/>
+                <a:ea typeface="Calibri" pitchFamily="34" charset="-122"/>
+                <a:cs typeface="Calibri" pitchFamily="34" charset="-120"/>
+              </a:rPr>
+              <a:t>Bought</a:t>
+            </a:r>
+            <a:endParaRPr lang="en-US" sz="1400" dirty="0"/>
+          </a:p>
+        </p:txBody>
+      </p:sp>
+      <p:sp>
+        <p:nvSpPr>
+          <p:cNvPr id="16" name="Text 14"/>
+          <p:cNvSpPr/>
+          <p:nvPr/>
+        </p:nvSpPr>
+        <p:spPr>
+          <a:xfrm>
+            <a:off x="8595360" y="2514600"/>
+            <a:ext cx="2834640" cy="457200"/>
+          </a:xfrm>
+          <a:prstGeom prst="rect">
+            <a:avLst/>
+          </a:prstGeom>
+          <a:noFill/>
+          <a:ln/>
+        </p:spPr>
+        <p:txBody>
+          <a:bodyPr wrap="square" lIns="0" tIns="0" rIns="0" bIns="0" rtlCol="0" anchor="ctr"/>
+          <a:lstStyle/>
+          <a:p>
+            <a:pPr indent="0" marL="0">
+              <a:buNone/>
+            </a:pPr>
+            <a:r>
+              <a:rPr lang="en-US" sz="2000" b="1" dirty="0">
+                <a:solidFill>
+                  <a:srgbClr val="F5EDE0"/>
+                </a:solidFill>
+                <a:latin typeface="Palatino Linotype" pitchFamily="34" charset="0"/>
+                <a:ea typeface="Palatino Linotype" pitchFamily="34" charset="-122"/>
+                <a:cs typeface="Palatino Linotype" pitchFamily="34" charset="-120"/>
+              </a:rPr>
+              <a:t>Đ3,082,860</a:t>
+            </a:r>
+            <a:endParaRPr lang="en-US" sz="2000" dirty="0"/>
+          </a:p>
+        </p:txBody>
+      </p:sp>
+      <p:sp>
+        <p:nvSpPr>
+          <p:cNvPr id="17" name="Text 15"/>
+          <p:cNvSpPr/>
+          <p:nvPr/>
+        </p:nvSpPr>
+        <p:spPr>
+          <a:xfrm>
+            <a:off x="6400800" y="3127248"/>
+            <a:ext cx="2377440" cy="365760"/>
+          </a:xfrm>
+          <a:prstGeom prst="rect">
+            <a:avLst/>
+          </a:prstGeom>
+          <a:noFill/>
+          <a:ln/>
+        </p:spPr>
+        <p:txBody>
+          <a:bodyPr wrap="square" lIns="0" tIns="0" rIns="0" bIns="0" rtlCol="0" anchor="ctr"/>
+          <a:lstStyle/>
+          <a:p>
+            <a:pPr indent="0" marL="0">
+              <a:buNone/>
+            </a:pPr>
+            <a:r>
+              <a:rPr lang="en-US" sz="1400" dirty="0">
+                <a:solidFill>
+                  <a:srgbClr val="8FA898"/>
+                </a:solidFill>
+                <a:latin typeface="Calibri" pitchFamily="34" charset="0"/>
+                <a:ea typeface="Calibri" pitchFamily="34" charset="-122"/>
+                <a:cs typeface="Calibri" pitchFamily="34" charset="-120"/>
+              </a:rPr>
+              <a:t>Sold</a:t>
+            </a:r>
+            <a:endParaRPr lang="en-US" sz="1400" dirty="0"/>
+          </a:p>
+        </p:txBody>
+      </p:sp>
+      <p:sp>
+        <p:nvSpPr>
+          <p:cNvPr id="18" name="Text 16"/>
+          <p:cNvSpPr/>
+          <p:nvPr/>
+        </p:nvSpPr>
+        <p:spPr>
+          <a:xfrm>
+            <a:off x="8595360" y="3081528"/>
+            <a:ext cx="2834640" cy="457200"/>
+          </a:xfrm>
+          <a:prstGeom prst="rect">
+            <a:avLst/>
+          </a:prstGeom>
+          <a:noFill/>
+          <a:ln/>
+        </p:spPr>
+        <p:txBody>
+          <a:bodyPr wrap="square" lIns="0" tIns="0" rIns="0" bIns="0" rtlCol="0" anchor="ctr"/>
+          <a:lstStyle/>
+          <a:p>
+            <a:pPr indent="0" marL="0">
+              <a:buNone/>
+            </a:pPr>
+            <a:r>
+              <a:rPr lang="en-US" sz="2000" b="1" dirty="0">
+                <a:solidFill>
+                  <a:srgbClr val="F5EDE0"/>
+                </a:solidFill>
+                <a:latin typeface="Palatino Linotype" pitchFamily="34" charset="0"/>
+                <a:ea typeface="Palatino Linotype" pitchFamily="34" charset="-122"/>
+                <a:cs typeface="Palatino Linotype" pitchFamily="34" charset="-120"/>
+              </a:rPr>
+              <a:t>Đ2,500,000</a:t>
+            </a:r>
+            <a:endParaRPr lang="en-US" sz="2000" dirty="0"/>
+          </a:p>
+        </p:txBody>
+      </p:sp>
+      <p:sp>
+        <p:nvSpPr>
+          <p:cNvPr id="19" name="Text 17"/>
+          <p:cNvSpPr/>
+          <p:nvPr/>
+        </p:nvSpPr>
+        <p:spPr>
+          <a:xfrm>
+            <a:off x="6400800" y="3694176"/>
+            <a:ext cx="2377440" cy="365760"/>
+          </a:xfrm>
+          <a:prstGeom prst="rect">
+            <a:avLst/>
+          </a:prstGeom>
+          <a:noFill/>
+          <a:ln/>
+        </p:spPr>
+        <p:txBody>
+          <a:bodyPr wrap="square" lIns="0" tIns="0" rIns="0" bIns="0" rtlCol="0" anchor="ctr"/>
+          <a:lstStyle/>
+          <a:p>
+            <a:pPr indent="0" marL="0">
+              <a:buNone/>
+            </a:pPr>
+            <a:r>
+              <a:rPr lang="en-US" sz="1400" dirty="0">
+                <a:solidFill>
+                  <a:srgbClr val="8FA898"/>
+                </a:solidFill>
+                <a:latin typeface="Calibri" pitchFamily="34" charset="0"/>
+                <a:ea typeface="Calibri" pitchFamily="34" charset="-122"/>
+                <a:cs typeface="Calibri" pitchFamily="34" charset="-120"/>
+              </a:rPr>
+              <a:t>Held</a:t>
+            </a:r>
+            <a:endParaRPr lang="en-US" sz="1400" dirty="0"/>
+          </a:p>
+        </p:txBody>
+      </p:sp>
+      <p:sp>
+        <p:nvSpPr>
+          <p:cNvPr id="20" name="Text 18"/>
+          <p:cNvSpPr/>
+          <p:nvPr/>
+        </p:nvSpPr>
+        <p:spPr>
+          <a:xfrm>
+            <a:off x="8595360" y="3648456"/>
+            <a:ext cx="2834640" cy="457200"/>
+          </a:xfrm>
+          <a:prstGeom prst="rect">
+            <a:avLst/>
+          </a:prstGeom>
+          <a:noFill/>
+          <a:ln/>
+        </p:spPr>
+        <p:txBody>
+          <a:bodyPr wrap="square" lIns="0" tIns="0" rIns="0" bIns="0" rtlCol="0" anchor="ctr"/>
+          <a:lstStyle/>
+          <a:p>
+            <a:pPr indent="0" marL="0">
+              <a:buNone/>
+            </a:pPr>
+            <a:r>
+              <a:rPr lang="en-US" sz="2000" b="1" dirty="0">
+                <a:solidFill>
+                  <a:srgbClr val="F5EDE0"/>
+                </a:solidFill>
+                <a:latin typeface="Palatino Linotype" pitchFamily="34" charset="0"/>
+                <a:ea typeface="Palatino Linotype" pitchFamily="34" charset="-122"/>
+                <a:cs typeface="Palatino Linotype" pitchFamily="34" charset="-120"/>
+              </a:rPr>
+              <a:t>21 months</a:t>
+            </a:r>
+            <a:endParaRPr lang="en-US" sz="2000" dirty="0"/>
+          </a:p>
+        </p:txBody>
+      </p:sp>
+      <p:sp>
+        <p:nvSpPr>
+          <p:cNvPr id="21" name="Text 19"/>
+          <p:cNvSpPr/>
+          <p:nvPr/>
+        </p:nvSpPr>
+        <p:spPr>
+          <a:xfrm>
+            <a:off x="6400800" y="4663440"/>
+            <a:ext cx="5029200" cy="822960"/>
+          </a:xfrm>
+          <a:prstGeom prst="rect">
+            <a:avLst/>
+          </a:prstGeom>
+          <a:noFill/>
+          <a:ln/>
+        </p:spPr>
+        <p:txBody>
+          <a:bodyPr wrap="square" lIns="0" tIns="0" rIns="0" bIns="0" rtlCol="0" anchor="ctr"/>
+          <a:lstStyle/>
+          <a:p>
+            <a:pPr indent="0" marL="0">
+              <a:buNone/>
+            </a:pPr>
+            <a:r>
+              <a:rPr lang="en-US" sz="4400" b="1" dirty="0">
+                <a:solidFill>
+                  <a:srgbClr val="C9A84C"/>
+                </a:solidFill>
+                <a:latin typeface="Palatino Linotype" pitchFamily="34" charset="0"/>
+                <a:ea typeface="Palatino Linotype" pitchFamily="34" charset="-122"/>
+                <a:cs typeface="Palatino Linotype" pitchFamily="34" charset="-120"/>
+              </a:rPr>
+              <a:t>−Đ582,860</a:t>
+            </a:r>
+            <a:endParaRPr lang="en-US" sz="4400" dirty="0"/>
+          </a:p>
+        </p:txBody>
+      </p:sp>
+      <p:sp>
+        <p:nvSpPr>
+          <p:cNvPr id="22" name="Shape 20"/>
+          <p:cNvSpPr/>
+          <p:nvPr/>
+        </p:nvSpPr>
+        <p:spPr>
+          <a:xfrm>
+            <a:off x="6094476" y="1463040"/>
+            <a:ext cx="0" cy="4206240"/>
+          </a:xfrm>
+          <a:prstGeom prst="line">
+            <a:avLst/>
+          </a:prstGeom>
+          <a:noFill/>
+          <a:ln w="19050">
+            <a:solidFill>
+              <a:srgbClr val="2E5A40"/>
+            </a:solidFill>
+            <a:prstDash val="solid"/>
+          </a:ln>
+        </p:spPr>
+      </p:sp>
+      <p:sp>
+        <p:nvSpPr>
+          <p:cNvPr id="23" name="Text 21"/>
+          <p:cNvSpPr/>
+          <p:nvPr/>
+        </p:nvSpPr>
+        <p:spPr>
+          <a:xfrm>
+            <a:off x="0" y="5943600"/>
+            <a:ext cx="12188952" cy="411480"/>
+          </a:xfrm>
+          <a:prstGeom prst="rect">
+            <a:avLst/>
+          </a:prstGeom>
+          <a:noFill/>
+          <a:ln/>
+        </p:spPr>
+        <p:txBody>
+          <a:bodyPr wrap="square" lIns="0" tIns="0" rIns="0" bIns="0" rtlCol="0" anchor="ctr"/>
+          <a:lstStyle/>
+          <a:p>
+            <a:pPr algn="ctr" indent="0" marL="0">
+              <a:buNone/>
+            </a:pPr>
+            <a:r>
+              <a:rPr lang="en-US" sz="2000" dirty="0">
+                <a:solidFill>
+                  <a:srgbClr val="F5EDE0"/>
+                </a:solidFill>
+                <a:latin typeface="Palatino Linotype" pitchFamily="34" charset="0"/>
+                <a:ea typeface="Palatino Linotype" pitchFamily="34" charset="-122"/>
+                <a:cs typeface="Palatino Linotype" pitchFamily="34" charset="-120"/>
+              </a:rPr>
+              <a:t>Same lagoons. The difference was the entry price.</a:t>
+            </a:r>
+            <a:endParaRPr lang="en-US" sz="2000" dirty="0"/>
+          </a:p>
+        </p:txBody>
+      </p:sp>
+    </p:spTree>
+  </p:cSld>
+  <p:clrMapOvr>
+    <a:masterClrMapping/>
+  </p:clrMapOvr>
+</p:sld>
+</file>
+
+<file path=ppt/slides/slide7.xml><?xml version="1.0" encoding="utf-8"?>
+<p:sld xmlns:a="http://schemas.openxmlformats.org/drawingml/2006/main" xmlns:r="http://schemas.openxmlformats.org/officeDocument/2006/relationships" xmlns:p="http://schemas.openxmlformats.org/presentationml/2006/main">
+  <p:cSld name="Slide 7">
+    <p:bg>
+      <p:bgPr>
+        <a:solidFill>
+          <a:srgbClr val="152A1F"/>
+        </a:solidFill>
+      </p:bgPr>
+    </p:bg>
+    <p:spTree>
+      <p:nvGrpSpPr>
+        <p:cNvPr id="1" name=""/>
+        <p:cNvGrpSpPr/>
+        <p:nvPr/>
+      </p:nvGrpSpPr>
+      <p:grpSpPr>
+        <a:xfrm>
+          <a:off x="0" y="0"/>
+          <a:ext cx="0" cy="0"/>
+          <a:chOff x="0" y="0"/>
+          <a:chExt cx="0" cy="0"/>
+        </a:xfrm>
+      </p:grpSpPr>
+      <p:sp>
+        <p:nvSpPr>
+          <p:cNvPr id="2" name="Text 0"/>
+          <p:cNvSpPr/>
+          <p:nvPr/>
+        </p:nvSpPr>
+        <p:spPr>
+          <a:xfrm>
+            <a:off x="0" y="384048"/>
+            <a:ext cx="12188952" cy="320040"/>
+          </a:xfrm>
+          <a:prstGeom prst="rect">
+            <a:avLst/>
+          </a:prstGeom>
+          <a:noFill/>
+          <a:ln/>
+        </p:spPr>
+        <p:txBody>
+          <a:bodyPr wrap="square" lIns="0" tIns="0" rIns="0" bIns="0" rtlCol="0" anchor="ctr"/>
+          <a:lstStyle/>
+          <a:p>
+            <a:pPr algn="ctr" indent="0" marL="0">
+              <a:buNone/>
+            </a:pPr>
+            <a:r>
+              <a:rPr lang="en-US" sz="1300" b="1" spc="400" kern="0" dirty="0">
+                <a:solidFill>
+                  <a:srgbClr val="C9A84C"/>
+                </a:solidFill>
+                <a:latin typeface="Calibri" pitchFamily="34" charset="0"/>
+                <a:ea typeface="Calibri" pitchFamily="34" charset="-122"/>
+                <a:cs typeface="Calibri" pitchFamily="34" charset="-120"/>
+              </a:rPr>
+              <a:t>THE VERDICT</a:t>
+            </a:r>
+            <a:endParaRPr lang="en-US" sz="1300" dirty="0"/>
+          </a:p>
+        </p:txBody>
+      </p:sp>
+      <p:sp>
+        <p:nvSpPr>
+          <p:cNvPr id="3" name="Text 1"/>
+          <p:cNvSpPr/>
+          <p:nvPr/>
+        </p:nvSpPr>
+        <p:spPr>
+          <a:xfrm>
+            <a:off x="11000232" y="384048"/>
+            <a:ext cx="640080" cy="320040"/>
+          </a:xfrm>
+          <a:prstGeom prst="rect">
+            <a:avLst/>
+          </a:prstGeom>
+          <a:noFill/>
+          <a:ln/>
+        </p:spPr>
+        <p:txBody>
+          <a:bodyPr wrap="square" lIns="0" tIns="0" rIns="0" bIns="0" rtlCol="0" anchor="ctr"/>
+          <a:lstStyle/>
+          <a:p>
+            <a:pPr algn="r" indent="0" marL="0">
+              <a:buNone/>
+            </a:pPr>
+            <a:r>
+              <a:rPr lang="en-US" sz="1200" b="1" dirty="0">
+                <a:solidFill>
+                  <a:srgbClr val="E8C96B"/>
+                </a:solidFill>
+                <a:latin typeface="Calibri" pitchFamily="34" charset="0"/>
+                <a:ea typeface="Calibri" pitchFamily="34" charset="-122"/>
+                <a:cs typeface="Calibri" pitchFamily="34" charset="-120"/>
+              </a:rPr>
+              <a:t>07</a:t>
             </a:r>
             <a:endParaRPr lang="en-US" sz="1200" dirty="0"/>
           </a:p>

</xml_diff>

<commit_message>
EP2 v4: ROE -31.5% and IRR -19.4% on 60/40 plan equity
</commit_message>
<xml_diff>
--- a/content-assets/lagoons-ep2/lagoons-ep2-gone-wrong.pptx
+++ b/content-assets/lagoons-ep2/lagoons-ep2-gone-wrong.pptx
@@ -1988,7 +1988,7 @@
                 <a:ea typeface="Palatino Linotype" pitchFamily="34" charset="-122"/>
                 <a:cs typeface="Palatino Linotype" pitchFamily="34" charset="-120"/>
               </a:rPr>
-              <a:t>−18.9%</a:t>
+              <a:t>−31.5%</a:t>
             </a:r>
             <a:endParaRPr lang="en-US" sz="2800" dirty="0"/>
           </a:p>
@@ -2066,7 +2066,7 @@
                 <a:ea typeface="Palatino Linotype" pitchFamily="34" charset="-122"/>
                 <a:cs typeface="Palatino Linotype" pitchFamily="34" charset="-120"/>
               </a:rPr>
-              <a:t>−11.3% / yr</a:t>
+              <a:t>−19.4% / yr</a:t>
             </a:r>
             <a:endParaRPr lang="en-US" sz="2800" dirty="0"/>
           </a:p>
@@ -2105,7 +2105,7 @@
                 <a:ea typeface="Palatino Linotype" pitchFamily="34" charset="-122"/>
                 <a:cs typeface="Palatino Linotype" pitchFamily="34" charset="-120"/>
               </a:rPr>
-              <a:t>Đ27,755 lost for every month held - bought at the developer’s 2024 release price</a:t>
+              <a:t>60/40 plan: Đ1,849,716 in → Đ1,266,856 back · Đ27,755 lost per month held</a:t>
             </a:r>
             <a:endParaRPr lang="en-US" sz="1800" dirty="0"/>
           </a:p>
@@ -3217,7 +3217,7 @@
                 <a:ea typeface="Palatino Linotype" pitchFamily="34" charset="-122"/>
                 <a:cs typeface="Palatino Linotype" pitchFamily="34" charset="-120"/>
               </a:rPr>
-              <a:t>−18.9%</a:t>
+              <a:t>−31.5%</a:t>
             </a:r>
             <a:endParaRPr lang="en-US" sz="2800" dirty="0"/>
           </a:p>
@@ -3295,7 +3295,7 @@
                 <a:ea typeface="Palatino Linotype" pitchFamily="34" charset="-122"/>
                 <a:cs typeface="Palatino Linotype" pitchFamily="34" charset="-120"/>
               </a:rPr>
-              <a:t>−11.3% / yr</a:t>
+              <a:t>−19.4% / yr</a:t>
             </a:r>
             <a:endParaRPr lang="en-US" sz="2800" dirty="0"/>
           </a:p>
@@ -3334,7 +3334,7 @@
                 <a:ea typeface="Palatino Linotype" pitchFamily="34" charset="-122"/>
                 <a:cs typeface="Palatino Linotype" pitchFamily="34" charset="-120"/>
               </a:rPr>
-              <a:t>Đ27,755 lost for every month held - bought at the developer’s 2024 release price</a:t>
+              <a:t>60/40 plan: Đ1,849,716 in → Đ1,266,856 back · Đ27,755 lost per month held</a:t>
             </a:r>
             <a:endParaRPr lang="en-US" sz="1800" dirty="0"/>
           </a:p>

</xml_diff>

<commit_message>
EP2 v5: DLD included - loss 706K, ROI -22.0, ROE -35.8, IRR -22.4
</commit_message>
<xml_diff>
--- a/content-assets/lagoons-ep2/lagoons-ep2-gone-wrong.pptx
+++ b/content-assets/lagoons-ep2/lagoons-ep2-gone-wrong.pptx
@@ -1481,7 +1481,7 @@
                 <a:ea typeface="Calibri" pitchFamily="34" charset="-122"/>
                 <a:cs typeface="Calibri" pitchFamily="34" charset="-120"/>
               </a:rPr>
-              <a:t>Bought from the developer</a:t>
+              <a:t>Bought (incl. 4% DLD)</a:t>
             </a:r>
             <a:endParaRPr lang="en-US" sz="1500" dirty="0"/>
           </a:p>
@@ -1520,7 +1520,7 @@
                 <a:ea typeface="Palatino Linotype" pitchFamily="34" charset="-122"/>
                 <a:cs typeface="Palatino Linotype" pitchFamily="34" charset="-120"/>
               </a:rPr>
-              <a:t>Đ3,082,860  ·  Sep 2024</a:t>
+              <a:t>Đ3,206,174  ·  Sep 2024</a:t>
             </a:r>
             <a:endParaRPr lang="en-US" sz="2500" dirty="0"/>
           </a:p>
@@ -1832,7 +1832,7 @@
                 <a:ea typeface="Palatino Linotype" pitchFamily="34" charset="-122"/>
                 <a:cs typeface="Palatino Linotype" pitchFamily="34" charset="-120"/>
               </a:rPr>
-              <a:t>−Đ582,860</a:t>
+              <a:t>−Đ706,174</a:t>
             </a:r>
             <a:endParaRPr lang="en-US" sz="5000" dirty="0"/>
           </a:p>
@@ -1910,7 +1910,7 @@
                 <a:ea typeface="Palatino Linotype" pitchFamily="34" charset="-122"/>
                 <a:cs typeface="Palatino Linotype" pitchFamily="34" charset="-120"/>
               </a:rPr>
-              <a:t>−18.9%</a:t>
+              <a:t>−22.0%</a:t>
             </a:r>
             <a:endParaRPr lang="en-US" sz="2800" dirty="0"/>
           </a:p>
@@ -1988,7 +1988,7 @@
                 <a:ea typeface="Palatino Linotype" pitchFamily="34" charset="-122"/>
                 <a:cs typeface="Palatino Linotype" pitchFamily="34" charset="-120"/>
               </a:rPr>
-              <a:t>−31.5%</a:t>
+              <a:t>−35.8%</a:t>
             </a:r>
             <a:endParaRPr lang="en-US" sz="2800" dirty="0"/>
           </a:p>
@@ -2066,7 +2066,7 @@
                 <a:ea typeface="Palatino Linotype" pitchFamily="34" charset="-122"/>
                 <a:cs typeface="Palatino Linotype" pitchFamily="34" charset="-120"/>
               </a:rPr>
-              <a:t>−19.4% / yr</a:t>
+              <a:t>−22.4% / yr</a:t>
             </a:r>
             <a:endParaRPr lang="en-US" sz="2800" dirty="0"/>
           </a:p>
@@ -2105,7 +2105,7 @@
                 <a:ea typeface="Palatino Linotype" pitchFamily="34" charset="-122"/>
                 <a:cs typeface="Palatino Linotype" pitchFamily="34" charset="-120"/>
               </a:rPr>
-              <a:t>60/40 plan: Đ1,849,716 in → Đ1,266,856 back · Đ27,755 lost per month held</a:t>
+              <a:t>60/40 plan + DLD: Đ1,973,030 in → Đ1,266,856 back · Đ33,627 lost per month held</a:t>
             </a:r>
             <a:endParaRPr lang="en-US" sz="1800" dirty="0"/>
           </a:p>
@@ -2710,7 +2710,7 @@
                 <a:ea typeface="Calibri" pitchFamily="34" charset="-122"/>
                 <a:cs typeface="Calibri" pitchFamily="34" charset="-120"/>
               </a:rPr>
-              <a:t>Bought from the developer</a:t>
+              <a:t>Bought (incl. 4% DLD)</a:t>
             </a:r>
             <a:endParaRPr lang="en-US" sz="1500" dirty="0"/>
           </a:p>
@@ -2749,7 +2749,7 @@
                 <a:ea typeface="Palatino Linotype" pitchFamily="34" charset="-122"/>
                 <a:cs typeface="Palatino Linotype" pitchFamily="34" charset="-120"/>
               </a:rPr>
-              <a:t>Đ3,082,860  ·  Sep 2024</a:t>
+              <a:t>Đ3,206,174  ·  Sep 2024</a:t>
             </a:r>
             <a:endParaRPr lang="en-US" sz="2500" dirty="0"/>
           </a:p>
@@ -3061,7 +3061,7 @@
                 <a:ea typeface="Palatino Linotype" pitchFamily="34" charset="-122"/>
                 <a:cs typeface="Palatino Linotype" pitchFamily="34" charset="-120"/>
               </a:rPr>
-              <a:t>−Đ582,860</a:t>
+              <a:t>−Đ706,174</a:t>
             </a:r>
             <a:endParaRPr lang="en-US" sz="5000" dirty="0"/>
           </a:p>
@@ -3139,7 +3139,7 @@
                 <a:ea typeface="Palatino Linotype" pitchFamily="34" charset="-122"/>
                 <a:cs typeface="Palatino Linotype" pitchFamily="34" charset="-120"/>
               </a:rPr>
-              <a:t>−18.9%</a:t>
+              <a:t>−22.0%</a:t>
             </a:r>
             <a:endParaRPr lang="en-US" sz="2800" dirty="0"/>
           </a:p>
@@ -3217,7 +3217,7 @@
                 <a:ea typeface="Palatino Linotype" pitchFamily="34" charset="-122"/>
                 <a:cs typeface="Palatino Linotype" pitchFamily="34" charset="-120"/>
               </a:rPr>
-              <a:t>−31.5%</a:t>
+              <a:t>−35.8%</a:t>
             </a:r>
             <a:endParaRPr lang="en-US" sz="2800" dirty="0"/>
           </a:p>
@@ -3295,7 +3295,7 @@
                 <a:ea typeface="Palatino Linotype" pitchFamily="34" charset="-122"/>
                 <a:cs typeface="Palatino Linotype" pitchFamily="34" charset="-120"/>
               </a:rPr>
-              <a:t>−19.4% / yr</a:t>
+              <a:t>−22.4% / yr</a:t>
             </a:r>
             <a:endParaRPr lang="en-US" sz="2800" dirty="0"/>
           </a:p>
@@ -3334,7 +3334,7 @@
                 <a:ea typeface="Palatino Linotype" pitchFamily="34" charset="-122"/>
                 <a:cs typeface="Palatino Linotype" pitchFamily="34" charset="-120"/>
               </a:rPr>
-              <a:t>60/40 plan: Đ1,849,716 in → Đ1,266,856 back · Đ27,755 lost per month held</a:t>
+              <a:t>60/40 plan + DLD: Đ1,973,030 in → Đ1,266,856 back · Đ33,627 lost per month held</a:t>
             </a:r>
             <a:endParaRPr lang="en-US" sz="1800" dirty="0"/>
           </a:p>
@@ -3561,7 +3561,7 @@
                 <a:ea typeface="Calibri" pitchFamily="34" charset="-122"/>
                 <a:cs typeface="Calibri" pitchFamily="34" charset="-120"/>
               </a:rPr>
-              <a:t>Bought</a:t>
+              <a:t>Bought (incl. DLD)</a:t>
             </a:r>
             <a:endParaRPr lang="en-US" sz="1400" dirty="0"/>
           </a:p>
@@ -3600,7 +3600,7 @@
                 <a:ea typeface="Palatino Linotype" pitchFamily="34" charset="-122"/>
                 <a:cs typeface="Palatino Linotype" pitchFamily="34" charset="-120"/>
               </a:rPr>
-              <a:t>Đ1,789,000</a:t>
+              <a:t>Đ1,860,560</a:t>
             </a:r>
             <a:endParaRPr lang="en-US" sz="2000" dirty="0"/>
           </a:p>
@@ -3912,7 +3912,7 @@
                 <a:ea typeface="Calibri" pitchFamily="34" charset="-122"/>
                 <a:cs typeface="Calibri" pitchFamily="34" charset="-120"/>
               </a:rPr>
-              <a:t>Bought</a:t>
+              <a:t>Bought (incl. DLD)</a:t>
             </a:r>
             <a:endParaRPr lang="en-US" sz="1400" dirty="0"/>
           </a:p>
@@ -3951,7 +3951,7 @@
                 <a:ea typeface="Palatino Linotype" pitchFamily="34" charset="-122"/>
                 <a:cs typeface="Palatino Linotype" pitchFamily="34" charset="-120"/>
               </a:rPr>
-              <a:t>Đ3,082,860</a:t>
+              <a:t>Đ3,206,174</a:t>
             </a:r>
             <a:endParaRPr lang="en-US" sz="2000" dirty="0"/>
           </a:p>
@@ -4146,7 +4146,7 @@
                 <a:ea typeface="Palatino Linotype" pitchFamily="34" charset="-122"/>
                 <a:cs typeface="Palatino Linotype" pitchFamily="34" charset="-120"/>
               </a:rPr>
-              <a:t>−Đ582,860</a:t>
+              <a:t>−Đ706,174</a:t>
             </a:r>
             <a:endParaRPr lang="en-US" sz="4400" dirty="0"/>
           </a:p>

</xml_diff>